<commit_message>
Deploying to gh-pages from @ LynneYan/LynneYan.github.io@6107d1f839843f3ba4352cd5500ea5eb8f42251e 🚀
</commit_message>
<xml_diff>
--- a/assets/img/publication_preview/ResizeFig.pptx
+++ b/assets/img/publication_preview/ResizeFig.pptx
@@ -199,7 +199,7 @@
           <a:p>
             <a:fld id="{1EC351A2-1F6F-FB41-A492-9787B897B92F}" type="datetimeFigureOut">
               <a:rPr lang="en-US" smtClean="0"/>
-              <a:t>10/1/23</a:t>
+              <a:t>6/8/26</a:t>
             </a:fld>
             <a:endParaRPr lang="en-US"/>
           </a:p>
@@ -781,7 +781,7 @@
           <a:p>
             <a:fld id="{83602AFC-2B03-0E49-8BA3-75A735F6B22F}" type="datetimeFigureOut">
               <a:rPr lang="en-US" smtClean="0"/>
-              <a:t>10/1/23</a:t>
+              <a:t>6/8/26</a:t>
             </a:fld>
             <a:endParaRPr lang="en-US"/>
           </a:p>
@@ -979,7 +979,7 @@
           <a:p>
             <a:fld id="{83602AFC-2B03-0E49-8BA3-75A735F6B22F}" type="datetimeFigureOut">
               <a:rPr lang="en-US" smtClean="0"/>
-              <a:t>10/1/23</a:t>
+              <a:t>6/8/26</a:t>
             </a:fld>
             <a:endParaRPr lang="en-US"/>
           </a:p>
@@ -1187,7 +1187,7 @@
           <a:p>
             <a:fld id="{83602AFC-2B03-0E49-8BA3-75A735F6B22F}" type="datetimeFigureOut">
               <a:rPr lang="en-US" smtClean="0"/>
-              <a:t>10/1/23</a:t>
+              <a:t>6/8/26</a:t>
             </a:fld>
             <a:endParaRPr lang="en-US"/>
           </a:p>
@@ -1385,7 +1385,7 @@
           <a:p>
             <a:fld id="{83602AFC-2B03-0E49-8BA3-75A735F6B22F}" type="datetimeFigureOut">
               <a:rPr lang="en-US" smtClean="0"/>
-              <a:t>10/1/23</a:t>
+              <a:t>6/8/26</a:t>
             </a:fld>
             <a:endParaRPr lang="en-US"/>
           </a:p>
@@ -1660,7 +1660,7 @@
           <a:p>
             <a:fld id="{83602AFC-2B03-0E49-8BA3-75A735F6B22F}" type="datetimeFigureOut">
               <a:rPr lang="en-US" smtClean="0"/>
-              <a:t>10/1/23</a:t>
+              <a:t>6/8/26</a:t>
             </a:fld>
             <a:endParaRPr lang="en-US"/>
           </a:p>
@@ -1925,7 +1925,7 @@
           <a:p>
             <a:fld id="{83602AFC-2B03-0E49-8BA3-75A735F6B22F}" type="datetimeFigureOut">
               <a:rPr lang="en-US" smtClean="0"/>
-              <a:t>10/1/23</a:t>
+              <a:t>6/8/26</a:t>
             </a:fld>
             <a:endParaRPr lang="en-US"/>
           </a:p>
@@ -2337,7 +2337,7 @@
           <a:p>
             <a:fld id="{83602AFC-2B03-0E49-8BA3-75A735F6B22F}" type="datetimeFigureOut">
               <a:rPr lang="en-US" smtClean="0"/>
-              <a:t>10/1/23</a:t>
+              <a:t>6/8/26</a:t>
             </a:fld>
             <a:endParaRPr lang="en-US"/>
           </a:p>
@@ -2478,7 +2478,7 @@
           <a:p>
             <a:fld id="{83602AFC-2B03-0E49-8BA3-75A735F6B22F}" type="datetimeFigureOut">
               <a:rPr lang="en-US" smtClean="0"/>
-              <a:t>10/1/23</a:t>
+              <a:t>6/8/26</a:t>
             </a:fld>
             <a:endParaRPr lang="en-US"/>
           </a:p>
@@ -2591,7 +2591,7 @@
           <a:p>
             <a:fld id="{83602AFC-2B03-0E49-8BA3-75A735F6B22F}" type="datetimeFigureOut">
               <a:rPr lang="en-US" smtClean="0"/>
-              <a:t>10/1/23</a:t>
+              <a:t>6/8/26</a:t>
             </a:fld>
             <a:endParaRPr lang="en-US"/>
           </a:p>
@@ -2902,7 +2902,7 @@
           <a:p>
             <a:fld id="{83602AFC-2B03-0E49-8BA3-75A735F6B22F}" type="datetimeFigureOut">
               <a:rPr lang="en-US" smtClean="0"/>
-              <a:t>10/1/23</a:t>
+              <a:t>6/8/26</a:t>
             </a:fld>
             <a:endParaRPr lang="en-US"/>
           </a:p>
@@ -3190,7 +3190,7 @@
           <a:p>
             <a:fld id="{83602AFC-2B03-0E49-8BA3-75A735F6B22F}" type="datetimeFigureOut">
               <a:rPr lang="en-US" smtClean="0"/>
-              <a:t>10/1/23</a:t>
+              <a:t>6/8/26</a:t>
             </a:fld>
             <a:endParaRPr lang="en-US"/>
           </a:p>
@@ -3431,7 +3431,7 @@
           <a:p>
             <a:fld id="{83602AFC-2B03-0E49-8BA3-75A735F6B22F}" type="datetimeFigureOut">
               <a:rPr lang="en-US" smtClean="0"/>
-              <a:t>10/1/23</a:t>
+              <a:t>6/8/26</a:t>
             </a:fld>
             <a:endParaRPr lang="en-US"/>
           </a:p>
@@ -3895,6 +3895,3183 @@
           </a:p>
         </p:txBody>
       </p:sp>
+      <p:grpSp>
+        <p:nvGrpSpPr>
+          <p:cNvPr id="119" name="Group 118">
+            <a:extLst>
+              <a:ext uri="{FF2B5EF4-FFF2-40B4-BE49-F238E27FC236}">
+                <a16:creationId xmlns:a16="http://schemas.microsoft.com/office/drawing/2014/main" id="{E10DA288-165F-553B-3533-E39E3E581243}"/>
+              </a:ext>
+            </a:extLst>
+          </p:cNvPr>
+          <p:cNvGrpSpPr/>
+          <p:nvPr/>
+        </p:nvGrpSpPr>
+        <p:grpSpPr>
+          <a:xfrm>
+            <a:off x="3263771" y="379795"/>
+            <a:ext cx="5469470" cy="6098410"/>
+            <a:chOff x="3263771" y="379795"/>
+            <a:chExt cx="5469470" cy="6098410"/>
+          </a:xfrm>
+        </p:grpSpPr>
+        <p:pic>
+          <p:nvPicPr>
+            <p:cNvPr id="13" name="Picture 12">
+              <a:extLst>
+                <a:ext uri="{FF2B5EF4-FFF2-40B4-BE49-F238E27FC236}">
+                  <a16:creationId xmlns:a16="http://schemas.microsoft.com/office/drawing/2014/main" id="{E6FB7371-932B-8B9A-F2A0-D5D73A15AC47}"/>
+                </a:ext>
+              </a:extLst>
+            </p:cNvPr>
+            <p:cNvPicPr>
+              <a:picLocks noChangeAspect="1"/>
+            </p:cNvPicPr>
+            <p:nvPr/>
+          </p:nvPicPr>
+          <p:blipFill>
+            <a:blip r:embed="rId3"/>
+            <a:stretch>
+              <a:fillRect/>
+            </a:stretch>
+          </p:blipFill>
+          <p:spPr>
+            <a:xfrm>
+              <a:off x="3267856" y="3697043"/>
+              <a:ext cx="5250774" cy="2781162"/>
+            </a:xfrm>
+            <a:prstGeom prst="rect">
+              <a:avLst/>
+            </a:prstGeom>
+          </p:spPr>
+        </p:pic>
+        <p:grpSp>
+          <p:nvGrpSpPr>
+            <p:cNvPr id="118" name="Group 117">
+              <a:extLst>
+                <a:ext uri="{FF2B5EF4-FFF2-40B4-BE49-F238E27FC236}">
+                  <a16:creationId xmlns:a16="http://schemas.microsoft.com/office/drawing/2014/main" id="{0A8E1CF6-122E-527D-004F-6F5B1B8BC9D1}"/>
+                </a:ext>
+              </a:extLst>
+            </p:cNvPr>
+            <p:cNvGrpSpPr/>
+            <p:nvPr/>
+          </p:nvGrpSpPr>
+          <p:grpSpPr>
+            <a:xfrm>
+              <a:off x="3263771" y="379795"/>
+              <a:ext cx="5469470" cy="2871582"/>
+              <a:chOff x="19516" y="-12439"/>
+              <a:chExt cx="3352483" cy="1760121"/>
+            </a:xfrm>
+          </p:grpSpPr>
+          <p:sp>
+            <p:nvSpPr>
+              <p:cNvPr id="66" name="Rectangle 65">
+                <a:extLst>
+                  <a:ext uri="{FF2B5EF4-FFF2-40B4-BE49-F238E27FC236}">
+                    <a16:creationId xmlns:a16="http://schemas.microsoft.com/office/drawing/2014/main" id="{6339C7CF-C4C9-6A5A-AEAF-18FA11B909A8}"/>
+                  </a:ext>
+                </a:extLst>
+              </p:cNvPr>
+              <p:cNvSpPr/>
+              <p:nvPr/>
+            </p:nvSpPr>
+            <p:spPr>
+              <a:xfrm>
+                <a:off x="233567" y="178656"/>
+                <a:ext cx="2115140" cy="1381583"/>
+              </a:xfrm>
+              <a:prstGeom prst="rect">
+                <a:avLst/>
+              </a:prstGeom>
+              <a:solidFill>
+                <a:schemeClr val="bg2"/>
+              </a:solidFill>
+              <a:ln>
+                <a:noFill/>
+              </a:ln>
+            </p:spPr>
+            <p:style>
+              <a:lnRef idx="2">
+                <a:schemeClr val="accent1">
+                  <a:shade val="15000"/>
+                </a:schemeClr>
+              </a:lnRef>
+              <a:fillRef idx="1">
+                <a:schemeClr val="accent1"/>
+              </a:fillRef>
+              <a:effectRef idx="0">
+                <a:schemeClr val="accent1"/>
+              </a:effectRef>
+              <a:fontRef idx="minor">
+                <a:schemeClr val="lt1"/>
+              </a:fontRef>
+            </p:style>
+            <p:txBody>
+              <a:bodyPr rtlCol="0" anchor="ctr"/>
+              <a:lstStyle/>
+              <a:p>
+                <a:pPr algn="ctr"/>
+                <a:endParaRPr lang="en-US" sz="1200">
+                  <a:ea typeface="Helvetica Neue" panose="02000503000000020004" pitchFamily="2" charset="0"/>
+                  <a:cs typeface="Helvetica Neue" panose="02000503000000020004" pitchFamily="2" charset="0"/>
+                </a:endParaRPr>
+              </a:p>
+            </p:txBody>
+          </p:sp>
+          <p:sp>
+            <p:nvSpPr>
+              <p:cNvPr id="67" name="Rectangle 66">
+                <a:extLst>
+                  <a:ext uri="{FF2B5EF4-FFF2-40B4-BE49-F238E27FC236}">
+                    <a16:creationId xmlns:a16="http://schemas.microsoft.com/office/drawing/2014/main" id="{32973FA8-0571-18BC-F07E-83DC7B38C87C}"/>
+                  </a:ext>
+                </a:extLst>
+              </p:cNvPr>
+              <p:cNvSpPr/>
+              <p:nvPr/>
+            </p:nvSpPr>
+            <p:spPr>
+              <a:xfrm>
+                <a:off x="2345145" y="174344"/>
+                <a:ext cx="837061" cy="1385894"/>
+              </a:xfrm>
+              <a:prstGeom prst="rect">
+                <a:avLst/>
+              </a:prstGeom>
+              <a:solidFill>
+                <a:schemeClr val="tx2">
+                  <a:lumMod val="10000"/>
+                  <a:lumOff val="90000"/>
+                </a:schemeClr>
+              </a:solidFill>
+              <a:ln>
+                <a:noFill/>
+              </a:ln>
+            </p:spPr>
+            <p:style>
+              <a:lnRef idx="2">
+                <a:schemeClr val="accent1">
+                  <a:shade val="15000"/>
+                </a:schemeClr>
+              </a:lnRef>
+              <a:fillRef idx="1">
+                <a:schemeClr val="accent1"/>
+              </a:fillRef>
+              <a:effectRef idx="0">
+                <a:schemeClr val="accent1"/>
+              </a:effectRef>
+              <a:fontRef idx="minor">
+                <a:schemeClr val="lt1"/>
+              </a:fontRef>
+            </p:style>
+            <p:txBody>
+              <a:bodyPr rtlCol="0" anchor="ctr"/>
+              <a:lstStyle/>
+              <a:p>
+                <a:pPr algn="ctr"/>
+                <a:endParaRPr lang="en-US" sz="1200" dirty="0">
+                  <a:ea typeface="Helvetica Neue" panose="02000503000000020004" pitchFamily="2" charset="0"/>
+                  <a:cs typeface="Helvetica Neue" panose="02000503000000020004" pitchFamily="2" charset="0"/>
+                </a:endParaRPr>
+              </a:p>
+            </p:txBody>
+          </p:sp>
+          <p:sp>
+            <p:nvSpPr>
+              <p:cNvPr id="68" name="Oval 67">
+                <a:extLst>
+                  <a:ext uri="{FF2B5EF4-FFF2-40B4-BE49-F238E27FC236}">
+                    <a16:creationId xmlns:a16="http://schemas.microsoft.com/office/drawing/2014/main" id="{61E0EA85-8F4D-11E4-F099-7660B4B61806}"/>
+                  </a:ext>
+                </a:extLst>
+              </p:cNvPr>
+              <p:cNvSpPr/>
+              <p:nvPr/>
+            </p:nvSpPr>
+            <p:spPr>
+              <a:xfrm>
+                <a:off x="2322224" y="436106"/>
+                <a:ext cx="225433" cy="225433"/>
+              </a:xfrm>
+              <a:prstGeom prst="ellipse">
+                <a:avLst/>
+              </a:prstGeom>
+              <a:solidFill>
+                <a:schemeClr val="bg1"/>
+              </a:solidFill>
+              <a:ln w="9525">
+                <a:solidFill>
+                  <a:schemeClr val="tx1">
+                    <a:lumMod val="50000"/>
+                    <a:lumOff val="50000"/>
+                  </a:schemeClr>
+                </a:solidFill>
+                <a:prstDash val="sysDash"/>
+              </a:ln>
+            </p:spPr>
+            <p:style>
+              <a:lnRef idx="2">
+                <a:schemeClr val="accent1"/>
+              </a:lnRef>
+              <a:fillRef idx="0">
+                <a:schemeClr val="accent1"/>
+              </a:fillRef>
+              <a:effectRef idx="1">
+                <a:schemeClr val="accent1"/>
+              </a:effectRef>
+              <a:fontRef idx="minor">
+                <a:schemeClr val="tx1"/>
+              </a:fontRef>
+            </p:style>
+            <p:txBody>
+              <a:bodyPr rtlCol="0" anchor="ctr"/>
+              <a:lstStyle/>
+              <a:p>
+                <a:pPr algn="ctr"/>
+                <a:endParaRPr lang="en-US" sz="1200">
+                  <a:ea typeface="Helvetica Neue" panose="02000503000000020004" pitchFamily="2" charset="0"/>
+                  <a:cs typeface="Helvetica Neue" panose="02000503000000020004" pitchFamily="2" charset="0"/>
+                </a:endParaRPr>
+              </a:p>
+            </p:txBody>
+          </p:sp>
+          <p:sp>
+            <p:nvSpPr>
+              <p:cNvPr id="69" name="Freeform 68">
+                <a:extLst>
+                  <a:ext uri="{FF2B5EF4-FFF2-40B4-BE49-F238E27FC236}">
+                    <a16:creationId xmlns:a16="http://schemas.microsoft.com/office/drawing/2014/main" id="{7414053A-7211-2D36-288E-EC5C32FFE787}"/>
+                  </a:ext>
+                </a:extLst>
+              </p:cNvPr>
+              <p:cNvSpPr/>
+              <p:nvPr/>
+            </p:nvSpPr>
+            <p:spPr>
+              <a:xfrm>
+                <a:off x="274005" y="190468"/>
+                <a:ext cx="2604977" cy="1238978"/>
+              </a:xfrm>
+              <a:custGeom>
+                <a:avLst/>
+                <a:gdLst>
+                  <a:gd name="csX0" fmla="*/ 0 w 2604977"/>
+                  <a:gd name="csY0" fmla="*/ 1015554 h 1238978"/>
+                  <a:gd name="csX1" fmla="*/ 63795 w 2604977"/>
+                  <a:gd name="csY1" fmla="*/ 1121879 h 1238978"/>
+                  <a:gd name="csX2" fmla="*/ 170121 w 2604977"/>
+                  <a:gd name="csY2" fmla="*/ 872014 h 1238978"/>
+                  <a:gd name="csX3" fmla="*/ 345558 w 2604977"/>
+                  <a:gd name="csY3" fmla="*/ 202163 h 1238978"/>
+                  <a:gd name="csX4" fmla="*/ 712381 w 2604977"/>
+                  <a:gd name="csY4" fmla="*/ 1238837 h 1238978"/>
+                  <a:gd name="csX5" fmla="*/ 962246 w 2604977"/>
+                  <a:gd name="csY5" fmla="*/ 281907 h 1238978"/>
+                  <a:gd name="csX6" fmla="*/ 1323753 w 2604977"/>
+                  <a:gd name="csY6" fmla="*/ 983656 h 1238978"/>
+                  <a:gd name="csX7" fmla="*/ 1594884 w 2604977"/>
+                  <a:gd name="csY7" fmla="*/ 159633 h 1238978"/>
+                  <a:gd name="csX8" fmla="*/ 1977656 w 2604977"/>
+                  <a:gd name="csY8" fmla="*/ 1020870 h 1238978"/>
+                  <a:gd name="csX9" fmla="*/ 2275367 w 2604977"/>
+                  <a:gd name="csY9" fmla="*/ 144 h 1238978"/>
+                  <a:gd name="csX10" fmla="*/ 2604977 w 2604977"/>
+                  <a:gd name="csY10" fmla="*/ 962391 h 1238978"/>
+                </a:gdLst>
+                <a:ahLst/>
+                <a:cxnLst>
+                  <a:cxn ang="0">
+                    <a:pos x="csX0" y="csY0"/>
+                  </a:cxn>
+                  <a:cxn ang="0">
+                    <a:pos x="csX1" y="csY1"/>
+                  </a:cxn>
+                  <a:cxn ang="0">
+                    <a:pos x="csX2" y="csY2"/>
+                  </a:cxn>
+                  <a:cxn ang="0">
+                    <a:pos x="csX3" y="csY3"/>
+                  </a:cxn>
+                  <a:cxn ang="0">
+                    <a:pos x="csX4" y="csY4"/>
+                  </a:cxn>
+                  <a:cxn ang="0">
+                    <a:pos x="csX5" y="csY5"/>
+                  </a:cxn>
+                  <a:cxn ang="0">
+                    <a:pos x="csX6" y="csY6"/>
+                  </a:cxn>
+                  <a:cxn ang="0">
+                    <a:pos x="csX7" y="csY7"/>
+                  </a:cxn>
+                  <a:cxn ang="0">
+                    <a:pos x="csX8" y="csY8"/>
+                  </a:cxn>
+                  <a:cxn ang="0">
+                    <a:pos x="csX9" y="csY9"/>
+                  </a:cxn>
+                  <a:cxn ang="0">
+                    <a:pos x="csX10" y="csY10"/>
+                  </a:cxn>
+                </a:cxnLst>
+                <a:rect l="l" t="t" r="r" b="b"/>
+                <a:pathLst>
+                  <a:path w="2604977" h="1238978">
+                    <a:moveTo>
+                      <a:pt x="0" y="1015554"/>
+                    </a:moveTo>
+                    <a:cubicBezTo>
+                      <a:pt x="17721" y="1080678"/>
+                      <a:pt x="35442" y="1145802"/>
+                      <a:pt x="63795" y="1121879"/>
+                    </a:cubicBezTo>
+                    <a:cubicBezTo>
+                      <a:pt x="92148" y="1097956"/>
+                      <a:pt x="123161" y="1025300"/>
+                      <a:pt x="170121" y="872014"/>
+                    </a:cubicBezTo>
+                    <a:cubicBezTo>
+                      <a:pt x="217081" y="718728"/>
+                      <a:pt x="255181" y="141026"/>
+                      <a:pt x="345558" y="202163"/>
+                    </a:cubicBezTo>
+                    <a:cubicBezTo>
+                      <a:pt x="435935" y="263300"/>
+                      <a:pt x="609600" y="1225546"/>
+                      <a:pt x="712381" y="1238837"/>
+                    </a:cubicBezTo>
+                    <a:cubicBezTo>
+                      <a:pt x="815162" y="1252128"/>
+                      <a:pt x="860351" y="324437"/>
+                      <a:pt x="962246" y="281907"/>
+                    </a:cubicBezTo>
+                    <a:cubicBezTo>
+                      <a:pt x="1064141" y="239377"/>
+                      <a:pt x="1218313" y="1004035"/>
+                      <a:pt x="1323753" y="983656"/>
+                    </a:cubicBezTo>
+                    <a:cubicBezTo>
+                      <a:pt x="1429193" y="963277"/>
+                      <a:pt x="1485900" y="153431"/>
+                      <a:pt x="1594884" y="159633"/>
+                    </a:cubicBezTo>
+                    <a:cubicBezTo>
+                      <a:pt x="1703868" y="165835"/>
+                      <a:pt x="1864242" y="1047452"/>
+                      <a:pt x="1977656" y="1020870"/>
+                    </a:cubicBezTo>
+                    <a:cubicBezTo>
+                      <a:pt x="2091070" y="994288"/>
+                      <a:pt x="2170814" y="9890"/>
+                      <a:pt x="2275367" y="144"/>
+                    </a:cubicBezTo>
+                    <a:cubicBezTo>
+                      <a:pt x="2379920" y="-9602"/>
+                      <a:pt x="2492448" y="476394"/>
+                      <a:pt x="2604977" y="962391"/>
+                    </a:cubicBezTo>
+                  </a:path>
+                </a:pathLst>
+              </a:custGeom>
+              <a:noFill/>
+              <a:ln w="9525">
+                <a:solidFill>
+                  <a:schemeClr val="tx1">
+                    <a:lumMod val="85000"/>
+                    <a:lumOff val="15000"/>
+                  </a:schemeClr>
+                </a:solidFill>
+              </a:ln>
+            </p:spPr>
+            <p:style>
+              <a:lnRef idx="2">
+                <a:schemeClr val="accent1">
+                  <a:shade val="15000"/>
+                </a:schemeClr>
+              </a:lnRef>
+              <a:fillRef idx="1">
+                <a:schemeClr val="accent1"/>
+              </a:fillRef>
+              <a:effectRef idx="0">
+                <a:schemeClr val="accent1"/>
+              </a:effectRef>
+              <a:fontRef idx="minor">
+                <a:schemeClr val="lt1"/>
+              </a:fontRef>
+            </p:style>
+            <p:txBody>
+              <a:bodyPr rtlCol="0" anchor="ctr"/>
+              <a:lstStyle/>
+              <a:p>
+                <a:pPr algn="ctr"/>
+                <a:endParaRPr lang="en-US" sz="1200">
+                  <a:ea typeface="Helvetica Neue" panose="02000503000000020004" pitchFamily="2" charset="0"/>
+                  <a:cs typeface="Helvetica Neue" panose="02000503000000020004" pitchFamily="2" charset="0"/>
+                </a:endParaRPr>
+              </a:p>
+            </p:txBody>
+          </p:sp>
+          <p:grpSp>
+            <p:nvGrpSpPr>
+              <p:cNvPr id="70" name="Group 69">
+                <a:extLst>
+                  <a:ext uri="{FF2B5EF4-FFF2-40B4-BE49-F238E27FC236}">
+                    <a16:creationId xmlns:a16="http://schemas.microsoft.com/office/drawing/2014/main" id="{05FB2EF5-2497-95B0-0244-14F309AE2803}"/>
+                  </a:ext>
+                </a:extLst>
+              </p:cNvPr>
+              <p:cNvGrpSpPr/>
+              <p:nvPr/>
+            </p:nvGrpSpPr>
+            <p:grpSpPr>
+              <a:xfrm>
+                <a:off x="2057206" y="653987"/>
+                <a:ext cx="361179" cy="553285"/>
+                <a:chOff x="2715131" y="555151"/>
+                <a:chExt cx="580548" cy="949752"/>
+              </a:xfrm>
+            </p:grpSpPr>
+            <p:sp>
+              <p:nvSpPr>
+                <p:cNvPr id="71" name="Freeform 70">
+                  <a:extLst>
+                    <a:ext uri="{FF2B5EF4-FFF2-40B4-BE49-F238E27FC236}">
+                      <a16:creationId xmlns:a16="http://schemas.microsoft.com/office/drawing/2014/main" id="{1709CA86-F0BC-7864-DE13-B51D9EA38598}"/>
+                    </a:ext>
+                  </a:extLst>
+                </p:cNvPr>
+                <p:cNvSpPr/>
+                <p:nvPr/>
+              </p:nvSpPr>
+              <p:spPr>
+                <a:xfrm>
+                  <a:off x="3059250" y="555151"/>
+                  <a:ext cx="236429" cy="949752"/>
+                </a:xfrm>
+                <a:custGeom>
+                  <a:avLst/>
+                  <a:gdLst>
+                    <a:gd name="csX0" fmla="*/ 0 w 419986"/>
+                    <a:gd name="csY0" fmla="*/ 563526 h 941166"/>
+                    <a:gd name="csX1" fmla="*/ 37214 w 419986"/>
+                    <a:gd name="csY1" fmla="*/ 733646 h 941166"/>
+                    <a:gd name="csX2" fmla="*/ 170121 w 419986"/>
+                    <a:gd name="csY2" fmla="*/ 940981 h 941166"/>
+                    <a:gd name="csX3" fmla="*/ 281763 w 419986"/>
+                    <a:gd name="csY3" fmla="*/ 696432 h 941166"/>
+                    <a:gd name="csX4" fmla="*/ 356191 w 419986"/>
+                    <a:gd name="csY4" fmla="*/ 271130 h 941166"/>
+                    <a:gd name="csX5" fmla="*/ 419986 w 419986"/>
+                    <a:gd name="csY5" fmla="*/ 0 h 941166"/>
+                    <a:gd name="csX0" fmla="*/ 0 w 457200"/>
+                    <a:gd name="csY0" fmla="*/ 675167 h 1052807"/>
+                    <a:gd name="csX1" fmla="*/ 37214 w 457200"/>
+                    <a:gd name="csY1" fmla="*/ 845287 h 1052807"/>
+                    <a:gd name="csX2" fmla="*/ 170121 w 457200"/>
+                    <a:gd name="csY2" fmla="*/ 1052622 h 1052807"/>
+                    <a:gd name="csX3" fmla="*/ 281763 w 457200"/>
+                    <a:gd name="csY3" fmla="*/ 808073 h 1052807"/>
+                    <a:gd name="csX4" fmla="*/ 356191 w 457200"/>
+                    <a:gd name="csY4" fmla="*/ 382771 h 1052807"/>
+                    <a:gd name="csX5" fmla="*/ 457200 w 457200"/>
+                    <a:gd name="csY5" fmla="*/ 0 h 1052807"/>
+                    <a:gd name="csX0" fmla="*/ 0 w 478466"/>
+                    <a:gd name="csY0" fmla="*/ 738963 h 1116603"/>
+                    <a:gd name="csX1" fmla="*/ 37214 w 478466"/>
+                    <a:gd name="csY1" fmla="*/ 909083 h 1116603"/>
+                    <a:gd name="csX2" fmla="*/ 170121 w 478466"/>
+                    <a:gd name="csY2" fmla="*/ 1116418 h 1116603"/>
+                    <a:gd name="csX3" fmla="*/ 281763 w 478466"/>
+                    <a:gd name="csY3" fmla="*/ 871869 h 1116603"/>
+                    <a:gd name="csX4" fmla="*/ 356191 w 478466"/>
+                    <a:gd name="csY4" fmla="*/ 446567 h 1116603"/>
+                    <a:gd name="csX5" fmla="*/ 478466 w 478466"/>
+                    <a:gd name="csY5" fmla="*/ 0 h 1116603"/>
+                    <a:gd name="csX0" fmla="*/ 0 w 478466"/>
+                    <a:gd name="csY0" fmla="*/ 738963 h 1117312"/>
+                    <a:gd name="csX1" fmla="*/ 31898 w 478466"/>
+                    <a:gd name="csY1" fmla="*/ 946297 h 1117312"/>
+                    <a:gd name="csX2" fmla="*/ 170121 w 478466"/>
+                    <a:gd name="csY2" fmla="*/ 1116418 h 1117312"/>
+                    <a:gd name="csX3" fmla="*/ 281763 w 478466"/>
+                    <a:gd name="csY3" fmla="*/ 871869 h 1117312"/>
+                    <a:gd name="csX4" fmla="*/ 356191 w 478466"/>
+                    <a:gd name="csY4" fmla="*/ 446567 h 1117312"/>
+                    <a:gd name="csX5" fmla="*/ 478466 w 478466"/>
+                    <a:gd name="csY5" fmla="*/ 0 h 1117312"/>
+                    <a:gd name="csX0" fmla="*/ 0 w 478466"/>
+                    <a:gd name="csY0" fmla="*/ 738963 h 1149318"/>
+                    <a:gd name="csX1" fmla="*/ 154173 w 478466"/>
+                    <a:gd name="csY1" fmla="*/ 1105785 h 1149318"/>
+                    <a:gd name="csX2" fmla="*/ 170121 w 478466"/>
+                    <a:gd name="csY2" fmla="*/ 1116418 h 1149318"/>
+                    <a:gd name="csX3" fmla="*/ 281763 w 478466"/>
+                    <a:gd name="csY3" fmla="*/ 871869 h 1149318"/>
+                    <a:gd name="csX4" fmla="*/ 356191 w 478466"/>
+                    <a:gd name="csY4" fmla="*/ 446567 h 1149318"/>
+                    <a:gd name="csX5" fmla="*/ 478466 w 478466"/>
+                    <a:gd name="csY5" fmla="*/ 0 h 1149318"/>
+                    <a:gd name="csX0" fmla="*/ 10830 w 324491"/>
+                    <a:gd name="csY0" fmla="*/ 1095154 h 1131989"/>
+                    <a:gd name="csX1" fmla="*/ 198 w 324491"/>
+                    <a:gd name="csY1" fmla="*/ 1105785 h 1131989"/>
+                    <a:gd name="csX2" fmla="*/ 16146 w 324491"/>
+                    <a:gd name="csY2" fmla="*/ 1116418 h 1131989"/>
+                    <a:gd name="csX3" fmla="*/ 127788 w 324491"/>
+                    <a:gd name="csY3" fmla="*/ 871869 h 1131989"/>
+                    <a:gd name="csX4" fmla="*/ 202216 w 324491"/>
+                    <a:gd name="csY4" fmla="*/ 446567 h 1131989"/>
+                    <a:gd name="csX5" fmla="*/ 324491 w 324491"/>
+                    <a:gd name="csY5" fmla="*/ 0 h 1131989"/>
+                    <a:gd name="csX0" fmla="*/ 4659 w 318320"/>
+                    <a:gd name="csY0" fmla="*/ 1095154 h 1129420"/>
+                    <a:gd name="csX1" fmla="*/ 9975 w 318320"/>
+                    <a:gd name="csY1" fmla="*/ 1116418 h 1129420"/>
+                    <a:gd name="csX2" fmla="*/ 121617 w 318320"/>
+                    <a:gd name="csY2" fmla="*/ 871869 h 1129420"/>
+                    <a:gd name="csX3" fmla="*/ 196045 w 318320"/>
+                    <a:gd name="csY3" fmla="*/ 446567 h 1129420"/>
+                    <a:gd name="csX4" fmla="*/ 318320 w 318320"/>
+                    <a:gd name="csY4" fmla="*/ 0 h 1129420"/>
+                    <a:gd name="csX0" fmla="*/ 4659 w 265014"/>
+                    <a:gd name="csY0" fmla="*/ 955738 h 990004"/>
+                    <a:gd name="csX1" fmla="*/ 9975 w 265014"/>
+                    <a:gd name="csY1" fmla="*/ 977002 h 990004"/>
+                    <a:gd name="csX2" fmla="*/ 121617 w 265014"/>
+                    <a:gd name="csY2" fmla="*/ 732453 h 990004"/>
+                    <a:gd name="csX3" fmla="*/ 196045 w 265014"/>
+                    <a:gd name="csY3" fmla="*/ 307151 h 990004"/>
+                    <a:gd name="csX4" fmla="*/ 265014 w 265014"/>
+                    <a:gd name="csY4" fmla="*/ 0 h 990004"/>
+                    <a:gd name="csX0" fmla="*/ 0 w 260355"/>
+                    <a:gd name="csY0" fmla="*/ 955738 h 1004169"/>
+                    <a:gd name="csX1" fmla="*/ 28580 w 260355"/>
+                    <a:gd name="csY1" fmla="*/ 993353 h 1004169"/>
+                    <a:gd name="csX2" fmla="*/ 116958 w 260355"/>
+                    <a:gd name="csY2" fmla="*/ 732453 h 1004169"/>
+                    <a:gd name="csX3" fmla="*/ 191386 w 260355"/>
+                    <a:gd name="csY3" fmla="*/ 307151 h 1004169"/>
+                    <a:gd name="csX4" fmla="*/ 260355 w 260355"/>
+                    <a:gd name="csY4" fmla="*/ 0 h 1004169"/>
+                    <a:gd name="csX0" fmla="*/ 20620 w 234447"/>
+                    <a:gd name="csY0" fmla="*/ 1053840 h 1054710"/>
+                    <a:gd name="csX1" fmla="*/ 2672 w 234447"/>
+                    <a:gd name="csY1" fmla="*/ 993353 h 1054710"/>
+                    <a:gd name="csX2" fmla="*/ 91050 w 234447"/>
+                    <a:gd name="csY2" fmla="*/ 732453 h 1054710"/>
+                    <a:gd name="csX3" fmla="*/ 165478 w 234447"/>
+                    <a:gd name="csY3" fmla="*/ 307151 h 1054710"/>
+                    <a:gd name="csX4" fmla="*/ 234447 w 234447"/>
+                    <a:gd name="csY4" fmla="*/ 0 h 1054710"/>
+                    <a:gd name="csX0" fmla="*/ 50999 w 232256"/>
+                    <a:gd name="csY0" fmla="*/ 1070190 h 1070690"/>
+                    <a:gd name="csX1" fmla="*/ 481 w 232256"/>
+                    <a:gd name="csY1" fmla="*/ 993353 h 1070690"/>
+                    <a:gd name="csX2" fmla="*/ 88859 w 232256"/>
+                    <a:gd name="csY2" fmla="*/ 732453 h 1070690"/>
+                    <a:gd name="csX3" fmla="*/ 163287 w 232256"/>
+                    <a:gd name="csY3" fmla="*/ 307151 h 1070690"/>
+                    <a:gd name="csX4" fmla="*/ 232256 w 232256"/>
+                    <a:gd name="csY4" fmla="*/ 0 h 1070690"/>
+                    <a:gd name="csX0" fmla="*/ 0 w 231775"/>
+                    <a:gd name="csY0" fmla="*/ 993353 h 993353"/>
+                    <a:gd name="csX1" fmla="*/ 88378 w 231775"/>
+                    <a:gd name="csY1" fmla="*/ 732453 h 993353"/>
+                    <a:gd name="csX2" fmla="*/ 162806 w 231775"/>
+                    <a:gd name="csY2" fmla="*/ 307151 h 993353"/>
+                    <a:gd name="csX3" fmla="*/ 231775 w 231775"/>
+                    <a:gd name="csY3" fmla="*/ 0 h 993353"/>
+                    <a:gd name="csX0" fmla="*/ 0 w 199205"/>
+                    <a:gd name="csY0" fmla="*/ 977003 h 977003"/>
+                    <a:gd name="csX1" fmla="*/ 55808 w 199205"/>
+                    <a:gd name="csY1" fmla="*/ 732453 h 977003"/>
+                    <a:gd name="csX2" fmla="*/ 130236 w 199205"/>
+                    <a:gd name="csY2" fmla="*/ 307151 h 977003"/>
+                    <a:gd name="csX3" fmla="*/ 199205 w 199205"/>
+                    <a:gd name="csY3" fmla="*/ 0 h 977003"/>
+                    <a:gd name="csX0" fmla="*/ 0 w 236427"/>
+                    <a:gd name="csY0" fmla="*/ 949752 h 949752"/>
+                    <a:gd name="csX1" fmla="*/ 93030 w 236427"/>
+                    <a:gd name="csY1" fmla="*/ 732453 h 949752"/>
+                    <a:gd name="csX2" fmla="*/ 167458 w 236427"/>
+                    <a:gd name="csY2" fmla="*/ 307151 h 949752"/>
+                    <a:gd name="csX3" fmla="*/ 236427 w 236427"/>
+                    <a:gd name="csY3" fmla="*/ 0 h 949752"/>
+                  </a:gdLst>
+                  <a:ahLst/>
+                  <a:cxnLst>
+                    <a:cxn ang="0">
+                      <a:pos x="csX0" y="csY0"/>
+                    </a:cxn>
+                    <a:cxn ang="0">
+                      <a:pos x="csX1" y="csY1"/>
+                    </a:cxn>
+                    <a:cxn ang="0">
+                      <a:pos x="csX2" y="csY2"/>
+                    </a:cxn>
+                    <a:cxn ang="0">
+                      <a:pos x="csX3" y="csY3"/>
+                    </a:cxn>
+                  </a:cxnLst>
+                  <a:rect l="l" t="t" r="r" b="b"/>
+                  <a:pathLst>
+                    <a:path w="236427" h="949752">
+                      <a:moveTo>
+                        <a:pt x="0" y="949752"/>
+                      </a:moveTo>
+                      <a:cubicBezTo>
+                        <a:pt x="6310" y="893463"/>
+                        <a:pt x="65120" y="839553"/>
+                        <a:pt x="93030" y="732453"/>
+                      </a:cubicBezTo>
+                      <a:cubicBezTo>
+                        <a:pt x="120940" y="625353"/>
+                        <a:pt x="144421" y="423223"/>
+                        <a:pt x="167458" y="307151"/>
+                      </a:cubicBezTo>
+                      <a:cubicBezTo>
+                        <a:pt x="190495" y="191079"/>
+                        <a:pt x="216048" y="77529"/>
+                        <a:pt x="236427" y="0"/>
+                      </a:cubicBezTo>
+                    </a:path>
+                  </a:pathLst>
+                </a:custGeom>
+                <a:noFill/>
+                <a:ln w="31750">
+                  <a:gradFill flip="none" rotWithShape="1">
+                    <a:gsLst>
+                      <a:gs pos="0">
+                        <a:schemeClr val="accent2">
+                          <a:lumMod val="67000"/>
+                        </a:schemeClr>
+                      </a:gs>
+                      <a:gs pos="49000">
+                        <a:schemeClr val="accent2">
+                          <a:lumMod val="97000"/>
+                          <a:lumOff val="3000"/>
+                        </a:schemeClr>
+                      </a:gs>
+                      <a:gs pos="100000">
+                        <a:schemeClr val="accent2">
+                          <a:lumMod val="60000"/>
+                          <a:lumOff val="40000"/>
+                        </a:schemeClr>
+                      </a:gs>
+                    </a:gsLst>
+                    <a:path path="circle">
+                      <a:fillToRect l="100000" b="100000"/>
+                    </a:path>
+                    <a:tileRect t="-100000" r="-100000"/>
+                  </a:gradFill>
+                  <a:tailEnd type="triangle" w="med" len="lg"/>
+                </a:ln>
+              </p:spPr>
+              <p:style>
+                <a:lnRef idx="2">
+                  <a:schemeClr val="accent1">
+                    <a:shade val="15000"/>
+                  </a:schemeClr>
+                </a:lnRef>
+                <a:fillRef idx="1">
+                  <a:schemeClr val="accent1"/>
+                </a:fillRef>
+                <a:effectRef idx="0">
+                  <a:schemeClr val="accent1"/>
+                </a:effectRef>
+                <a:fontRef idx="minor">
+                  <a:schemeClr val="lt1"/>
+                </a:fontRef>
+              </p:style>
+              <p:txBody>
+                <a:bodyPr rtlCol="0" anchor="ctr"/>
+                <a:lstStyle/>
+                <a:p>
+                  <a:pPr algn="ctr"/>
+                  <a:endParaRPr lang="en-US" sz="1200" dirty="0">
+                    <a:ea typeface="Helvetica Neue" panose="02000503000000020004" pitchFamily="2" charset="0"/>
+                    <a:cs typeface="Helvetica Neue" panose="02000503000000020004" pitchFamily="2" charset="0"/>
+                  </a:endParaRPr>
+                </a:p>
+              </p:txBody>
+            </p:sp>
+            <p:sp>
+              <p:nvSpPr>
+                <p:cNvPr id="72" name="Freeform 71">
+                  <a:extLst>
+                    <a:ext uri="{FF2B5EF4-FFF2-40B4-BE49-F238E27FC236}">
+                      <a16:creationId xmlns:a16="http://schemas.microsoft.com/office/drawing/2014/main" id="{F504E1DA-92E0-6AC8-2526-DB10A32A0A03}"/>
+                    </a:ext>
+                  </a:extLst>
+                </p:cNvPr>
+                <p:cNvSpPr/>
+                <p:nvPr/>
+              </p:nvSpPr>
+              <p:spPr>
+                <a:xfrm>
+                  <a:off x="2715131" y="675850"/>
+                  <a:ext cx="333437" cy="806327"/>
+                </a:xfrm>
+                <a:custGeom>
+                  <a:avLst/>
+                  <a:gdLst>
+                    <a:gd name="csX0" fmla="*/ 0 w 419986"/>
+                    <a:gd name="csY0" fmla="*/ 563526 h 941166"/>
+                    <a:gd name="csX1" fmla="*/ 37214 w 419986"/>
+                    <a:gd name="csY1" fmla="*/ 733646 h 941166"/>
+                    <a:gd name="csX2" fmla="*/ 170121 w 419986"/>
+                    <a:gd name="csY2" fmla="*/ 940981 h 941166"/>
+                    <a:gd name="csX3" fmla="*/ 281763 w 419986"/>
+                    <a:gd name="csY3" fmla="*/ 696432 h 941166"/>
+                    <a:gd name="csX4" fmla="*/ 356191 w 419986"/>
+                    <a:gd name="csY4" fmla="*/ 271130 h 941166"/>
+                    <a:gd name="csX5" fmla="*/ 419986 w 419986"/>
+                    <a:gd name="csY5" fmla="*/ 0 h 941166"/>
+                    <a:gd name="csX0" fmla="*/ 0 w 457200"/>
+                    <a:gd name="csY0" fmla="*/ 675167 h 1052807"/>
+                    <a:gd name="csX1" fmla="*/ 37214 w 457200"/>
+                    <a:gd name="csY1" fmla="*/ 845287 h 1052807"/>
+                    <a:gd name="csX2" fmla="*/ 170121 w 457200"/>
+                    <a:gd name="csY2" fmla="*/ 1052622 h 1052807"/>
+                    <a:gd name="csX3" fmla="*/ 281763 w 457200"/>
+                    <a:gd name="csY3" fmla="*/ 808073 h 1052807"/>
+                    <a:gd name="csX4" fmla="*/ 356191 w 457200"/>
+                    <a:gd name="csY4" fmla="*/ 382771 h 1052807"/>
+                    <a:gd name="csX5" fmla="*/ 457200 w 457200"/>
+                    <a:gd name="csY5" fmla="*/ 0 h 1052807"/>
+                    <a:gd name="csX0" fmla="*/ 0 w 478466"/>
+                    <a:gd name="csY0" fmla="*/ 738963 h 1116603"/>
+                    <a:gd name="csX1" fmla="*/ 37214 w 478466"/>
+                    <a:gd name="csY1" fmla="*/ 909083 h 1116603"/>
+                    <a:gd name="csX2" fmla="*/ 170121 w 478466"/>
+                    <a:gd name="csY2" fmla="*/ 1116418 h 1116603"/>
+                    <a:gd name="csX3" fmla="*/ 281763 w 478466"/>
+                    <a:gd name="csY3" fmla="*/ 871869 h 1116603"/>
+                    <a:gd name="csX4" fmla="*/ 356191 w 478466"/>
+                    <a:gd name="csY4" fmla="*/ 446567 h 1116603"/>
+                    <a:gd name="csX5" fmla="*/ 478466 w 478466"/>
+                    <a:gd name="csY5" fmla="*/ 0 h 1116603"/>
+                    <a:gd name="csX0" fmla="*/ 0 w 356191"/>
+                    <a:gd name="csY0" fmla="*/ 292396 h 670036"/>
+                    <a:gd name="csX1" fmla="*/ 37214 w 356191"/>
+                    <a:gd name="csY1" fmla="*/ 462516 h 670036"/>
+                    <a:gd name="csX2" fmla="*/ 170121 w 356191"/>
+                    <a:gd name="csY2" fmla="*/ 669851 h 670036"/>
+                    <a:gd name="csX3" fmla="*/ 281763 w 356191"/>
+                    <a:gd name="csY3" fmla="*/ 425302 h 670036"/>
+                    <a:gd name="csX4" fmla="*/ 356191 w 356191"/>
+                    <a:gd name="csY4" fmla="*/ 0 h 670036"/>
+                    <a:gd name="csX0" fmla="*/ 0 w 281763"/>
+                    <a:gd name="csY0" fmla="*/ 0 h 377640"/>
+                    <a:gd name="csX1" fmla="*/ 37214 w 281763"/>
+                    <a:gd name="csY1" fmla="*/ 170120 h 377640"/>
+                    <a:gd name="csX2" fmla="*/ 170121 w 281763"/>
+                    <a:gd name="csY2" fmla="*/ 377455 h 377640"/>
+                    <a:gd name="csX3" fmla="*/ 281763 w 281763"/>
+                    <a:gd name="csY3" fmla="*/ 132906 h 377640"/>
+                    <a:gd name="csX0" fmla="*/ 0 w 170121"/>
+                    <a:gd name="csY0" fmla="*/ 0 h 377640"/>
+                    <a:gd name="csX1" fmla="*/ 37214 w 170121"/>
+                    <a:gd name="csY1" fmla="*/ 170120 h 377640"/>
+                    <a:gd name="csX2" fmla="*/ 170121 w 170121"/>
+                    <a:gd name="csY2" fmla="*/ 377455 h 377640"/>
+                    <a:gd name="csX0" fmla="*/ 0 w 235728"/>
+                    <a:gd name="csY0" fmla="*/ 0 h 566308"/>
+                    <a:gd name="csX1" fmla="*/ 102821 w 235728"/>
+                    <a:gd name="csY1" fmla="*/ 358741 h 566308"/>
+                    <a:gd name="csX2" fmla="*/ 235728 w 235728"/>
+                    <a:gd name="csY2" fmla="*/ 566076 h 566308"/>
+                    <a:gd name="csX0" fmla="*/ 0 w 310173"/>
+                    <a:gd name="csY0" fmla="*/ 0 h 866064"/>
+                    <a:gd name="csX1" fmla="*/ 177266 w 310173"/>
+                    <a:gd name="csY1" fmla="*/ 658497 h 866064"/>
+                    <a:gd name="csX2" fmla="*/ 310173 w 310173"/>
+                    <a:gd name="csY2" fmla="*/ 865832 h 866064"/>
+                    <a:gd name="csX0" fmla="*/ 0 w 333437"/>
+                    <a:gd name="csY0" fmla="*/ 0 h 806326"/>
+                    <a:gd name="csX1" fmla="*/ 177266 w 333437"/>
+                    <a:gd name="csY1" fmla="*/ 658497 h 806326"/>
+                    <a:gd name="csX2" fmla="*/ 333437 w 333437"/>
+                    <a:gd name="csY2" fmla="*/ 805881 h 806326"/>
+                  </a:gdLst>
+                  <a:ahLst/>
+                  <a:cxnLst>
+                    <a:cxn ang="0">
+                      <a:pos x="csX0" y="csY0"/>
+                    </a:cxn>
+                    <a:cxn ang="0">
+                      <a:pos x="csX1" y="csY1"/>
+                    </a:cxn>
+                    <a:cxn ang="0">
+                      <a:pos x="csX2" y="csY2"/>
+                    </a:cxn>
+                  </a:cxnLst>
+                  <a:rect l="l" t="t" r="r" b="b"/>
+                  <a:pathLst>
+                    <a:path w="333437" h="806326">
+                      <a:moveTo>
+                        <a:pt x="0" y="0"/>
+                      </a:moveTo>
+                      <a:cubicBezTo>
+                        <a:pt x="4430" y="53605"/>
+                        <a:pt x="137978" y="564151"/>
+                        <a:pt x="177266" y="658497"/>
+                      </a:cubicBezTo>
+                      <a:cubicBezTo>
+                        <a:pt x="216554" y="752843"/>
+                        <a:pt x="292679" y="812083"/>
+                        <a:pt x="333437" y="805881"/>
+                      </a:cubicBezTo>
+                    </a:path>
+                  </a:pathLst>
+                </a:custGeom>
+                <a:noFill/>
+                <a:ln w="31750">
+                  <a:gradFill flip="none" rotWithShape="1">
+                    <a:gsLst>
+                      <a:gs pos="0">
+                        <a:schemeClr val="accent2">
+                          <a:lumMod val="60000"/>
+                          <a:lumOff val="40000"/>
+                          <a:alpha val="0"/>
+                        </a:schemeClr>
+                      </a:gs>
+                      <a:gs pos="64000">
+                        <a:schemeClr val="accent2">
+                          <a:lumMod val="60000"/>
+                          <a:lumOff val="40000"/>
+                          <a:alpha val="52033"/>
+                        </a:schemeClr>
+                      </a:gs>
+                      <a:gs pos="100000">
+                        <a:schemeClr val="accent2">
+                          <a:lumMod val="60000"/>
+                          <a:lumOff val="40000"/>
+                        </a:schemeClr>
+                      </a:gs>
+                    </a:gsLst>
+                    <a:lin ang="2700000" scaled="1"/>
+                    <a:tileRect/>
+                  </a:gradFill>
+                  <a:tailEnd type="none" w="med" len="lg"/>
+                </a:ln>
+              </p:spPr>
+              <p:style>
+                <a:lnRef idx="2">
+                  <a:schemeClr val="accent1">
+                    <a:shade val="15000"/>
+                  </a:schemeClr>
+                </a:lnRef>
+                <a:fillRef idx="1">
+                  <a:schemeClr val="accent1"/>
+                </a:fillRef>
+                <a:effectRef idx="0">
+                  <a:schemeClr val="accent1"/>
+                </a:effectRef>
+                <a:fontRef idx="minor">
+                  <a:schemeClr val="lt1"/>
+                </a:fontRef>
+              </p:style>
+              <p:txBody>
+                <a:bodyPr rtlCol="0" anchor="ctr"/>
+                <a:lstStyle/>
+                <a:p>
+                  <a:pPr algn="ctr"/>
+                  <a:endParaRPr lang="en-US" sz="1200" dirty="0">
+                    <a:ea typeface="Helvetica Neue" panose="02000503000000020004" pitchFamily="2" charset="0"/>
+                    <a:cs typeface="Helvetica Neue" panose="02000503000000020004" pitchFamily="2" charset="0"/>
+                  </a:endParaRPr>
+                </a:p>
+              </p:txBody>
+            </p:sp>
+          </p:grpSp>
+          <p:sp>
+            <p:nvSpPr>
+              <p:cNvPr id="73" name="Freeform 72">
+                <a:extLst>
+                  <a:ext uri="{FF2B5EF4-FFF2-40B4-BE49-F238E27FC236}">
+                    <a16:creationId xmlns:a16="http://schemas.microsoft.com/office/drawing/2014/main" id="{55D06D4C-9B27-8A16-F169-88CA9ED4C0E6}"/>
+                  </a:ext>
+                </a:extLst>
+              </p:cNvPr>
+              <p:cNvSpPr/>
+              <p:nvPr/>
+            </p:nvSpPr>
+            <p:spPr>
+              <a:xfrm>
+                <a:off x="257626" y="525716"/>
+                <a:ext cx="2062480" cy="263879"/>
+              </a:xfrm>
+              <a:custGeom>
+                <a:avLst/>
+                <a:gdLst>
+                  <a:gd name="csX0" fmla="*/ 0 w 2062480"/>
+                  <a:gd name="csY0" fmla="*/ 263879 h 263879"/>
+                  <a:gd name="csX1" fmla="*/ 238760 w 2062480"/>
+                  <a:gd name="csY1" fmla="*/ 253719 h 263879"/>
+                  <a:gd name="csX2" fmla="*/ 883920 w 2062480"/>
+                  <a:gd name="csY2" fmla="*/ 228319 h 263879"/>
+                  <a:gd name="csX3" fmla="*/ 1524000 w 2062480"/>
+                  <a:gd name="csY3" fmla="*/ 20039 h 263879"/>
+                  <a:gd name="csX4" fmla="*/ 2062480 w 2062480"/>
+                  <a:gd name="csY4" fmla="*/ 4799 h 263879"/>
+                </a:gdLst>
+                <a:ahLst/>
+                <a:cxnLst>
+                  <a:cxn ang="0">
+                    <a:pos x="csX0" y="csY0"/>
+                  </a:cxn>
+                  <a:cxn ang="0">
+                    <a:pos x="csX1" y="csY1"/>
+                  </a:cxn>
+                  <a:cxn ang="0">
+                    <a:pos x="csX2" y="csY2"/>
+                  </a:cxn>
+                  <a:cxn ang="0">
+                    <a:pos x="csX3" y="csY3"/>
+                  </a:cxn>
+                  <a:cxn ang="0">
+                    <a:pos x="csX4" y="csY4"/>
+                  </a:cxn>
+                </a:cxnLst>
+                <a:rect l="l" t="t" r="r" b="b"/>
+                <a:pathLst>
+                  <a:path w="2062480" h="263879">
+                    <a:moveTo>
+                      <a:pt x="0" y="263879"/>
+                    </a:moveTo>
+                    <a:lnTo>
+                      <a:pt x="238760" y="253719"/>
+                    </a:lnTo>
+                    <a:lnTo>
+                      <a:pt x="883920" y="228319"/>
+                    </a:lnTo>
+                    <a:cubicBezTo>
+                      <a:pt x="1098127" y="189372"/>
+                      <a:pt x="1327573" y="57292"/>
+                      <a:pt x="1524000" y="20039"/>
+                    </a:cubicBezTo>
+                    <a:cubicBezTo>
+                      <a:pt x="1720427" y="-17214"/>
+                      <a:pt x="1984587" y="9879"/>
+                      <a:pt x="2062480" y="4799"/>
+                    </a:cubicBezTo>
+                  </a:path>
+                </a:pathLst>
+              </a:custGeom>
+              <a:noFill/>
+              <a:ln w="31750">
+                <a:gradFill flip="none" rotWithShape="1">
+                  <a:gsLst>
+                    <a:gs pos="9000">
+                      <a:srgbClr val="0D8DBE">
+                        <a:alpha val="43519"/>
+                      </a:srgbClr>
+                    </a:gs>
+                    <a:gs pos="0">
+                      <a:schemeClr val="accent4">
+                        <a:lumMod val="89000"/>
+                        <a:alpha val="0"/>
+                      </a:schemeClr>
+                    </a:gs>
+                    <a:gs pos="46000">
+                      <a:schemeClr val="accent4">
+                        <a:lumMod val="89000"/>
+                        <a:alpha val="45000"/>
+                      </a:schemeClr>
+                    </a:gs>
+                    <a:gs pos="69000">
+                      <a:schemeClr val="accent4">
+                        <a:lumMod val="75000"/>
+                      </a:schemeClr>
+                    </a:gs>
+                    <a:gs pos="97000">
+                      <a:schemeClr val="accent4">
+                        <a:lumMod val="70000"/>
+                      </a:schemeClr>
+                    </a:gs>
+                  </a:gsLst>
+                  <a:lin ang="0" scaled="1"/>
+                  <a:tileRect/>
+                </a:gradFill>
+                <a:tailEnd type="triangle" w="med" len="lg"/>
+              </a:ln>
+            </p:spPr>
+            <p:style>
+              <a:lnRef idx="2">
+                <a:schemeClr val="accent1">
+                  <a:shade val="15000"/>
+                </a:schemeClr>
+              </a:lnRef>
+              <a:fillRef idx="1">
+                <a:schemeClr val="accent1"/>
+              </a:fillRef>
+              <a:effectRef idx="0">
+                <a:schemeClr val="accent1"/>
+              </a:effectRef>
+              <a:fontRef idx="minor">
+                <a:schemeClr val="lt1"/>
+              </a:fontRef>
+            </p:style>
+            <p:txBody>
+              <a:bodyPr rtlCol="0" anchor="ctr"/>
+              <a:lstStyle/>
+              <a:p>
+                <a:pPr algn="ctr"/>
+                <a:endParaRPr lang="en-US" sz="1200">
+                  <a:ea typeface="Helvetica Neue" panose="02000503000000020004" pitchFamily="2" charset="0"/>
+                  <a:cs typeface="Helvetica Neue" panose="02000503000000020004" pitchFamily="2" charset="0"/>
+                </a:endParaRPr>
+              </a:p>
+            </p:txBody>
+          </p:sp>
+          <p:sp>
+            <p:nvSpPr>
+              <p:cNvPr id="74" name="TextBox 73">
+                <a:extLst>
+                  <a:ext uri="{FF2B5EF4-FFF2-40B4-BE49-F238E27FC236}">
+                    <a16:creationId xmlns:a16="http://schemas.microsoft.com/office/drawing/2014/main" id="{F77DFFA2-5C64-CF66-4BF5-DAAC8549D98F}"/>
+                  </a:ext>
+                </a:extLst>
+              </p:cNvPr>
+              <p:cNvSpPr txBox="1"/>
+              <p:nvPr/>
+            </p:nvSpPr>
+            <p:spPr>
+              <a:xfrm>
+                <a:off x="310375" y="1571761"/>
+                <a:ext cx="2042717" cy="169785"/>
+              </a:xfrm>
+              <a:prstGeom prst="rect">
+                <a:avLst/>
+              </a:prstGeom>
+              <a:noFill/>
+            </p:spPr>
+            <p:txBody>
+              <a:bodyPr wrap="square">
+                <a:spAutoFit/>
+              </a:bodyPr>
+              <a:lstStyle/>
+              <a:p>
+                <a:pPr algn="ctr"/>
+                <a:r>
+                  <a:rPr lang="en-US" sz="1200" dirty="0">
+                    <a:ea typeface="Helvetica Neue" panose="02000503000000020004" pitchFamily="2" charset="0"/>
+                    <a:cs typeface="Helvetica Neue" panose="02000503000000020004" pitchFamily="2" charset="0"/>
+                  </a:rPr>
+                  <a:t>same calendar day across years</a:t>
+                </a:r>
+              </a:p>
+            </p:txBody>
+          </p:sp>
+          <p:sp>
+            <p:nvSpPr>
+              <p:cNvPr id="75" name="TextBox 74">
+                <a:extLst>
+                  <a:ext uri="{FF2B5EF4-FFF2-40B4-BE49-F238E27FC236}">
+                    <a16:creationId xmlns:a16="http://schemas.microsoft.com/office/drawing/2014/main" id="{1A63B92E-E36E-A30B-99F8-5D13BA0660C4}"/>
+                  </a:ext>
+                </a:extLst>
+              </p:cNvPr>
+              <p:cNvSpPr txBox="1"/>
+              <p:nvPr/>
+            </p:nvSpPr>
+            <p:spPr>
+              <a:xfrm>
+                <a:off x="2796429" y="1567175"/>
+                <a:ext cx="303805" cy="169785"/>
+              </a:xfrm>
+              <a:prstGeom prst="rect">
+                <a:avLst/>
+              </a:prstGeom>
+              <a:noFill/>
+            </p:spPr>
+            <p:txBody>
+              <a:bodyPr wrap="none" rtlCol="0">
+                <a:spAutoFit/>
+              </a:bodyPr>
+              <a:lstStyle/>
+              <a:p>
+                <a:r>
+                  <a:rPr lang="en-US" altLang="zh-CN" sz="1200" dirty="0">
+                    <a:ea typeface="Helvetica Neue" panose="02000503000000020004" pitchFamily="2" charset="0"/>
+                    <a:cs typeface="Helvetica Neue" panose="02000503000000020004" pitchFamily="2" charset="0"/>
+                  </a:rPr>
+                  <a:t>Time</a:t>
+                </a:r>
+                <a:endParaRPr lang="en-US" sz="1200" dirty="0">
+                  <a:ea typeface="Helvetica Neue" panose="02000503000000020004" pitchFamily="2" charset="0"/>
+                  <a:cs typeface="Helvetica Neue" panose="02000503000000020004" pitchFamily="2" charset="0"/>
+                </a:endParaRPr>
+              </a:p>
+            </p:txBody>
+          </p:sp>
+          <p:sp>
+            <p:nvSpPr>
+              <p:cNvPr id="76" name="TextBox 75">
+                <a:extLst>
+                  <a:ext uri="{FF2B5EF4-FFF2-40B4-BE49-F238E27FC236}">
+                    <a16:creationId xmlns:a16="http://schemas.microsoft.com/office/drawing/2014/main" id="{43875DFC-7B13-05DB-518B-A17CBA145D42}"/>
+                  </a:ext>
+                </a:extLst>
+              </p:cNvPr>
+              <p:cNvSpPr txBox="1"/>
+              <p:nvPr/>
+            </p:nvSpPr>
+            <p:spPr>
+              <a:xfrm rot="16200000">
+                <a:off x="-197510" y="756233"/>
+                <a:ext cx="603837" cy="169785"/>
+              </a:xfrm>
+              <a:prstGeom prst="rect">
+                <a:avLst/>
+              </a:prstGeom>
+              <a:noFill/>
+            </p:spPr>
+            <p:txBody>
+              <a:bodyPr wrap="none" rtlCol="0">
+                <a:spAutoFit/>
+              </a:bodyPr>
+              <a:lstStyle/>
+              <a:p>
+                <a:r>
+                  <a:rPr lang="en-US" altLang="zh-CN" sz="1200" dirty="0">
+                    <a:ea typeface="Helvetica Neue" panose="02000503000000020004" pitchFamily="2" charset="0"/>
+                    <a:cs typeface="Helvetica Neue" panose="02000503000000020004" pitchFamily="2" charset="0"/>
+                  </a:rPr>
+                  <a:t>Temperature</a:t>
+                </a:r>
+                <a:endParaRPr lang="en-US" sz="1200" dirty="0">
+                  <a:ea typeface="Helvetica Neue" panose="02000503000000020004" pitchFamily="2" charset="0"/>
+                  <a:cs typeface="Helvetica Neue" panose="02000503000000020004" pitchFamily="2" charset="0"/>
+                </a:endParaRPr>
+              </a:p>
+            </p:txBody>
+          </p:sp>
+          <p:cxnSp>
+            <p:nvCxnSpPr>
+              <p:cNvPr id="77" name="Straight Connector 76">
+                <a:extLst>
+                  <a:ext uri="{FF2B5EF4-FFF2-40B4-BE49-F238E27FC236}">
+                    <a16:creationId xmlns:a16="http://schemas.microsoft.com/office/drawing/2014/main" id="{005F649D-2042-5865-554C-A855B5FBA7D4}"/>
+                  </a:ext>
+                </a:extLst>
+              </p:cNvPr>
+              <p:cNvCxnSpPr>
+                <a:cxnSpLocks/>
+              </p:cNvCxnSpPr>
+              <p:nvPr/>
+            </p:nvCxnSpPr>
+            <p:spPr>
+              <a:xfrm flipV="1">
+                <a:off x="219274" y="107921"/>
+                <a:ext cx="12270" cy="1464071"/>
+              </a:xfrm>
+              <a:prstGeom prst="line">
+                <a:avLst/>
+              </a:prstGeom>
+              <a:ln w="9525">
+                <a:headEnd type="none"/>
+                <a:tailEnd type="triangle" w="sm" len="med"/>
+              </a:ln>
+            </p:spPr>
+            <p:style>
+              <a:lnRef idx="2">
+                <a:schemeClr val="dk1"/>
+              </a:lnRef>
+              <a:fillRef idx="0">
+                <a:schemeClr val="dk1"/>
+              </a:fillRef>
+              <a:effectRef idx="1">
+                <a:schemeClr val="dk1"/>
+              </a:effectRef>
+              <a:fontRef idx="minor">
+                <a:schemeClr val="tx1"/>
+              </a:fontRef>
+            </p:style>
+          </p:cxnSp>
+          <p:cxnSp>
+            <p:nvCxnSpPr>
+              <p:cNvPr id="78" name="Straight Connector 77">
+                <a:extLst>
+                  <a:ext uri="{FF2B5EF4-FFF2-40B4-BE49-F238E27FC236}">
+                    <a16:creationId xmlns:a16="http://schemas.microsoft.com/office/drawing/2014/main" id="{3F2C2C46-8CF4-EAF5-7F03-0062C0A52C32}"/>
+                  </a:ext>
+                </a:extLst>
+              </p:cNvPr>
+              <p:cNvCxnSpPr>
+                <a:cxnSpLocks/>
+              </p:cNvCxnSpPr>
+              <p:nvPr/>
+            </p:nvCxnSpPr>
+            <p:spPr>
+              <a:xfrm>
+                <a:off x="506648" y="792598"/>
+                <a:ext cx="0" cy="744984"/>
+              </a:xfrm>
+              <a:prstGeom prst="line">
+                <a:avLst/>
+              </a:prstGeom>
+              <a:ln w="9525">
+                <a:solidFill>
+                  <a:schemeClr val="tx1"/>
+                </a:solidFill>
+                <a:prstDash val="sysDash"/>
+              </a:ln>
+            </p:spPr>
+            <p:style>
+              <a:lnRef idx="2">
+                <a:schemeClr val="accent1"/>
+              </a:lnRef>
+              <a:fillRef idx="0">
+                <a:schemeClr val="accent1"/>
+              </a:fillRef>
+              <a:effectRef idx="1">
+                <a:schemeClr val="accent1"/>
+              </a:effectRef>
+              <a:fontRef idx="minor">
+                <a:schemeClr val="tx1"/>
+              </a:fontRef>
+            </p:style>
+          </p:cxnSp>
+          <p:cxnSp>
+            <p:nvCxnSpPr>
+              <p:cNvPr id="79" name="Straight Connector 78">
+                <a:extLst>
+                  <a:ext uri="{FF2B5EF4-FFF2-40B4-BE49-F238E27FC236}">
+                    <a16:creationId xmlns:a16="http://schemas.microsoft.com/office/drawing/2014/main" id="{6EE03EC3-6D63-3EC4-3AFA-D5F9F0B2E50B}"/>
+                  </a:ext>
+                </a:extLst>
+              </p:cNvPr>
+              <p:cNvCxnSpPr>
+                <a:cxnSpLocks/>
+              </p:cNvCxnSpPr>
+              <p:nvPr/>
+            </p:nvCxnSpPr>
+            <p:spPr>
+              <a:xfrm>
+                <a:off x="1152189" y="781512"/>
+                <a:ext cx="0" cy="799737"/>
+              </a:xfrm>
+              <a:prstGeom prst="line">
+                <a:avLst/>
+              </a:prstGeom>
+              <a:ln w="9525">
+                <a:solidFill>
+                  <a:schemeClr val="tx1"/>
+                </a:solidFill>
+                <a:prstDash val="sysDash"/>
+              </a:ln>
+            </p:spPr>
+            <p:style>
+              <a:lnRef idx="2">
+                <a:schemeClr val="accent1"/>
+              </a:lnRef>
+              <a:fillRef idx="0">
+                <a:schemeClr val="accent1"/>
+              </a:fillRef>
+              <a:effectRef idx="1">
+                <a:schemeClr val="accent1"/>
+              </a:effectRef>
+              <a:fontRef idx="minor">
+                <a:schemeClr val="tx1"/>
+              </a:fontRef>
+            </p:style>
+          </p:cxnSp>
+          <p:cxnSp>
+            <p:nvCxnSpPr>
+              <p:cNvPr id="80" name="Straight Connector 79">
+                <a:extLst>
+                  <a:ext uri="{FF2B5EF4-FFF2-40B4-BE49-F238E27FC236}">
+                    <a16:creationId xmlns:a16="http://schemas.microsoft.com/office/drawing/2014/main" id="{64C04797-955A-3185-1133-5ECF4FDC70CF}"/>
+                  </a:ext>
+                </a:extLst>
+              </p:cNvPr>
+              <p:cNvCxnSpPr>
+                <a:cxnSpLocks/>
+              </p:cNvCxnSpPr>
+              <p:nvPr/>
+            </p:nvCxnSpPr>
+            <p:spPr>
+              <a:xfrm>
+                <a:off x="1788406" y="536876"/>
+                <a:ext cx="0" cy="1093475"/>
+              </a:xfrm>
+              <a:prstGeom prst="line">
+                <a:avLst/>
+              </a:prstGeom>
+              <a:ln w="9525">
+                <a:solidFill>
+                  <a:schemeClr val="tx1"/>
+                </a:solidFill>
+                <a:prstDash val="sysDash"/>
+              </a:ln>
+            </p:spPr>
+            <p:style>
+              <a:lnRef idx="2">
+                <a:schemeClr val="accent1"/>
+              </a:lnRef>
+              <a:fillRef idx="0">
+                <a:schemeClr val="accent1"/>
+              </a:fillRef>
+              <a:effectRef idx="1">
+                <a:schemeClr val="accent1"/>
+              </a:effectRef>
+              <a:fontRef idx="minor">
+                <a:schemeClr val="tx1"/>
+              </a:fontRef>
+            </p:style>
+          </p:cxnSp>
+          <p:cxnSp>
+            <p:nvCxnSpPr>
+              <p:cNvPr id="81" name="Straight Connector 80">
+                <a:extLst>
+                  <a:ext uri="{FF2B5EF4-FFF2-40B4-BE49-F238E27FC236}">
+                    <a16:creationId xmlns:a16="http://schemas.microsoft.com/office/drawing/2014/main" id="{75791AAB-BB15-C08F-F0CE-C5600AB516FD}"/>
+                  </a:ext>
+                </a:extLst>
+              </p:cNvPr>
+              <p:cNvCxnSpPr>
+                <a:cxnSpLocks/>
+              </p:cNvCxnSpPr>
+              <p:nvPr/>
+            </p:nvCxnSpPr>
+            <p:spPr>
+              <a:xfrm flipH="1">
+                <a:off x="2427081" y="534340"/>
+                <a:ext cx="2487" cy="996681"/>
+              </a:xfrm>
+              <a:prstGeom prst="line">
+                <a:avLst/>
+              </a:prstGeom>
+              <a:ln w="9525">
+                <a:solidFill>
+                  <a:schemeClr val="tx1"/>
+                </a:solidFill>
+                <a:prstDash val="sysDash"/>
+              </a:ln>
+            </p:spPr>
+            <p:style>
+              <a:lnRef idx="2">
+                <a:schemeClr val="accent1"/>
+              </a:lnRef>
+              <a:fillRef idx="0">
+                <a:schemeClr val="accent1"/>
+              </a:fillRef>
+              <a:effectRef idx="1">
+                <a:schemeClr val="accent1"/>
+              </a:effectRef>
+              <a:fontRef idx="minor">
+                <a:schemeClr val="tx1"/>
+              </a:fontRef>
+            </p:style>
+          </p:cxnSp>
+          <p:sp>
+            <p:nvSpPr>
+              <p:cNvPr id="82" name="Oval 81">
+                <a:extLst>
+                  <a:ext uri="{FF2B5EF4-FFF2-40B4-BE49-F238E27FC236}">
+                    <a16:creationId xmlns:a16="http://schemas.microsoft.com/office/drawing/2014/main" id="{94976EBC-362C-B674-4AE4-FD58473473A5}"/>
+                  </a:ext>
+                </a:extLst>
+              </p:cNvPr>
+              <p:cNvSpPr/>
+              <p:nvPr/>
+            </p:nvSpPr>
+            <p:spPr>
+              <a:xfrm>
+                <a:off x="2375635" y="513993"/>
+                <a:ext cx="91440" cy="91440"/>
+              </a:xfrm>
+              <a:prstGeom prst="ellipse">
+                <a:avLst/>
+              </a:prstGeom>
+              <a:solidFill>
+                <a:schemeClr val="accent6">
+                  <a:lumMod val="75000"/>
+                </a:schemeClr>
+              </a:solidFill>
+              <a:ln w="9525"/>
+            </p:spPr>
+            <p:style>
+              <a:lnRef idx="2">
+                <a:schemeClr val="accent1">
+                  <a:shade val="15000"/>
+                </a:schemeClr>
+              </a:lnRef>
+              <a:fillRef idx="1">
+                <a:schemeClr val="accent1"/>
+              </a:fillRef>
+              <a:effectRef idx="0">
+                <a:schemeClr val="accent1"/>
+              </a:effectRef>
+              <a:fontRef idx="minor">
+                <a:schemeClr val="lt1"/>
+              </a:fontRef>
+            </p:style>
+            <p:txBody>
+              <a:bodyPr rtlCol="0" anchor="ctr"/>
+              <a:lstStyle/>
+              <a:p>
+                <a:pPr algn="ctr"/>
+                <a:endParaRPr lang="en-US" sz="1200">
+                  <a:ea typeface="Helvetica Neue" panose="02000503000000020004" pitchFamily="2" charset="0"/>
+                  <a:cs typeface="Helvetica Neue" panose="02000503000000020004" pitchFamily="2" charset="0"/>
+                </a:endParaRPr>
+              </a:p>
+            </p:txBody>
+          </p:sp>
+          <p:sp>
+            <p:nvSpPr>
+              <p:cNvPr id="83" name="Oval 82">
+                <a:extLst>
+                  <a:ext uri="{FF2B5EF4-FFF2-40B4-BE49-F238E27FC236}">
+                    <a16:creationId xmlns:a16="http://schemas.microsoft.com/office/drawing/2014/main" id="{7D8E2584-7C71-0837-8197-BC08912DBC0F}"/>
+                  </a:ext>
+                </a:extLst>
+              </p:cNvPr>
+              <p:cNvSpPr/>
+              <p:nvPr/>
+            </p:nvSpPr>
+            <p:spPr>
+              <a:xfrm>
+                <a:off x="459693" y="713692"/>
+                <a:ext cx="91440" cy="91440"/>
+              </a:xfrm>
+              <a:prstGeom prst="ellipse">
+                <a:avLst/>
+              </a:prstGeom>
+              <a:solidFill>
+                <a:srgbClr val="0070C0"/>
+              </a:solidFill>
+              <a:ln w="9525"/>
+            </p:spPr>
+            <p:style>
+              <a:lnRef idx="2">
+                <a:schemeClr val="accent1">
+                  <a:shade val="15000"/>
+                </a:schemeClr>
+              </a:lnRef>
+              <a:fillRef idx="1">
+                <a:schemeClr val="accent1"/>
+              </a:fillRef>
+              <a:effectRef idx="0">
+                <a:schemeClr val="accent1"/>
+              </a:effectRef>
+              <a:fontRef idx="minor">
+                <a:schemeClr val="lt1"/>
+              </a:fontRef>
+            </p:style>
+            <p:txBody>
+              <a:bodyPr rtlCol="0" anchor="ctr"/>
+              <a:lstStyle/>
+              <a:p>
+                <a:pPr algn="ctr"/>
+                <a:endParaRPr lang="en-US" sz="1200">
+                  <a:ea typeface="Helvetica Neue" panose="02000503000000020004" pitchFamily="2" charset="0"/>
+                  <a:cs typeface="Helvetica Neue" panose="02000503000000020004" pitchFamily="2" charset="0"/>
+                </a:endParaRPr>
+              </a:p>
+            </p:txBody>
+          </p:sp>
+          <p:sp>
+            <p:nvSpPr>
+              <p:cNvPr id="84" name="Oval 83">
+                <a:extLst>
+                  <a:ext uri="{FF2B5EF4-FFF2-40B4-BE49-F238E27FC236}">
+                    <a16:creationId xmlns:a16="http://schemas.microsoft.com/office/drawing/2014/main" id="{90B5367D-81C9-63DF-F2B8-B0C03DF622CD}"/>
+                  </a:ext>
+                </a:extLst>
+              </p:cNvPr>
+              <p:cNvSpPr/>
+              <p:nvPr/>
+            </p:nvSpPr>
+            <p:spPr>
+              <a:xfrm>
+                <a:off x="1107751" y="698119"/>
+                <a:ext cx="91440" cy="91440"/>
+              </a:xfrm>
+              <a:prstGeom prst="ellipse">
+                <a:avLst/>
+              </a:prstGeom>
+              <a:solidFill>
+                <a:srgbClr val="0070C0"/>
+              </a:solidFill>
+              <a:ln w="9525"/>
+            </p:spPr>
+            <p:style>
+              <a:lnRef idx="2">
+                <a:schemeClr val="accent1">
+                  <a:shade val="15000"/>
+                </a:schemeClr>
+              </a:lnRef>
+              <a:fillRef idx="1">
+                <a:schemeClr val="accent1"/>
+              </a:fillRef>
+              <a:effectRef idx="0">
+                <a:schemeClr val="accent1"/>
+              </a:effectRef>
+              <a:fontRef idx="minor">
+                <a:schemeClr val="lt1"/>
+              </a:fontRef>
+            </p:style>
+            <p:txBody>
+              <a:bodyPr rtlCol="0" anchor="ctr"/>
+              <a:lstStyle/>
+              <a:p>
+                <a:pPr algn="ctr"/>
+                <a:endParaRPr lang="en-US" sz="1200">
+                  <a:ea typeface="Helvetica Neue" panose="02000503000000020004" pitchFamily="2" charset="0"/>
+                  <a:cs typeface="Helvetica Neue" panose="02000503000000020004" pitchFamily="2" charset="0"/>
+                </a:endParaRPr>
+              </a:p>
+            </p:txBody>
+          </p:sp>
+          <p:sp>
+            <p:nvSpPr>
+              <p:cNvPr id="85" name="Oval 84">
+                <a:extLst>
+                  <a:ext uri="{FF2B5EF4-FFF2-40B4-BE49-F238E27FC236}">
+                    <a16:creationId xmlns:a16="http://schemas.microsoft.com/office/drawing/2014/main" id="{81AE5BD2-8F56-B4D0-1B90-0738FD0C4E20}"/>
+                  </a:ext>
+                </a:extLst>
+              </p:cNvPr>
+              <p:cNvSpPr/>
+              <p:nvPr/>
+            </p:nvSpPr>
+            <p:spPr>
+              <a:xfrm>
+                <a:off x="1738392" y="484149"/>
+                <a:ext cx="91440" cy="91440"/>
+              </a:xfrm>
+              <a:prstGeom prst="ellipse">
+                <a:avLst/>
+              </a:prstGeom>
+              <a:solidFill>
+                <a:srgbClr val="0070C0"/>
+              </a:solidFill>
+              <a:ln w="9525"/>
+            </p:spPr>
+            <p:style>
+              <a:lnRef idx="2">
+                <a:schemeClr val="accent1">
+                  <a:shade val="15000"/>
+                </a:schemeClr>
+              </a:lnRef>
+              <a:fillRef idx="1">
+                <a:schemeClr val="accent1"/>
+              </a:fillRef>
+              <a:effectRef idx="0">
+                <a:schemeClr val="accent1"/>
+              </a:effectRef>
+              <a:fontRef idx="minor">
+                <a:schemeClr val="lt1"/>
+              </a:fontRef>
+            </p:style>
+            <p:txBody>
+              <a:bodyPr rtlCol="0" anchor="ctr"/>
+              <a:lstStyle/>
+              <a:p>
+                <a:pPr algn="ctr"/>
+                <a:endParaRPr lang="en-US" sz="1200">
+                  <a:ea typeface="Helvetica Neue" panose="02000503000000020004" pitchFamily="2" charset="0"/>
+                  <a:cs typeface="Helvetica Neue" panose="02000503000000020004" pitchFamily="2" charset="0"/>
+                </a:endParaRPr>
+              </a:p>
+            </p:txBody>
+          </p:sp>
+          <p:sp>
+            <p:nvSpPr>
+              <p:cNvPr id="86" name="TextBox 85">
+                <a:extLst>
+                  <a:ext uri="{FF2B5EF4-FFF2-40B4-BE49-F238E27FC236}">
+                    <a16:creationId xmlns:a16="http://schemas.microsoft.com/office/drawing/2014/main" id="{EF197FC3-95B8-99DA-8356-C0E054BE73F4}"/>
+                  </a:ext>
+                </a:extLst>
+              </p:cNvPr>
+              <p:cNvSpPr txBox="1"/>
+              <p:nvPr/>
+            </p:nvSpPr>
+            <p:spPr>
+              <a:xfrm>
+                <a:off x="1635693" y="154300"/>
+                <a:ext cx="892258" cy="144553"/>
+              </a:xfrm>
+              <a:prstGeom prst="rect">
+                <a:avLst/>
+              </a:prstGeom>
+              <a:noFill/>
+            </p:spPr>
+            <p:txBody>
+              <a:bodyPr wrap="square">
+                <a:spAutoFit/>
+              </a:bodyPr>
+              <a:lstStyle/>
+              <a:p>
+                <a:pPr algn="ctr">
+                  <a:lnSpc>
+                    <a:spcPts val="1000"/>
+                  </a:lnSpc>
+                </a:pPr>
+                <a:r>
+                  <a:rPr lang="en-US" sz="1200" dirty="0">
+                    <a:solidFill>
+                      <a:schemeClr val="accent6">
+                        <a:lumMod val="75000"/>
+                      </a:schemeClr>
+                    </a:solidFill>
+                    <a:ea typeface="Helvetica Neue" panose="02000503000000020004" pitchFamily="2" charset="0"/>
+                    <a:cs typeface="Helvetica Neue" panose="02000503000000020004" pitchFamily="2" charset="0"/>
+                  </a:rPr>
+                  <a:t>Final prediction</a:t>
+                </a:r>
+              </a:p>
+            </p:txBody>
+          </p:sp>
+          <p:cxnSp>
+            <p:nvCxnSpPr>
+              <p:cNvPr id="87" name="Straight Arrow Connector 86">
+                <a:extLst>
+                  <a:ext uri="{FF2B5EF4-FFF2-40B4-BE49-F238E27FC236}">
+                    <a16:creationId xmlns:a16="http://schemas.microsoft.com/office/drawing/2014/main" id="{5A2C2453-444C-B38C-6A4F-DBE9A0B38780}"/>
+                  </a:ext>
+                </a:extLst>
+              </p:cNvPr>
+              <p:cNvCxnSpPr>
+                <a:cxnSpLocks/>
+                <a:endCxn id="82" idx="1"/>
+              </p:cNvCxnSpPr>
+              <p:nvPr/>
+            </p:nvCxnSpPr>
+            <p:spPr>
+              <a:xfrm>
+                <a:off x="2128545" y="310760"/>
+                <a:ext cx="260481" cy="216624"/>
+              </a:xfrm>
+              <a:prstGeom prst="straightConnector1">
+                <a:avLst/>
+              </a:prstGeom>
+              <a:ln w="12700">
+                <a:solidFill>
+                  <a:schemeClr val="accent6">
+                    <a:lumMod val="50000"/>
+                  </a:schemeClr>
+                </a:solidFill>
+                <a:tailEnd type="triangle" w="sm" len="med"/>
+              </a:ln>
+            </p:spPr>
+            <p:style>
+              <a:lnRef idx="2">
+                <a:schemeClr val="accent1"/>
+              </a:lnRef>
+              <a:fillRef idx="0">
+                <a:schemeClr val="accent1"/>
+              </a:fillRef>
+              <a:effectRef idx="1">
+                <a:schemeClr val="accent1"/>
+              </a:effectRef>
+              <a:fontRef idx="minor">
+                <a:schemeClr val="tx1"/>
+              </a:fontRef>
+            </p:style>
+          </p:cxnSp>
+          <p:sp>
+            <p:nvSpPr>
+              <p:cNvPr id="88" name="TextBox 87">
+                <a:extLst>
+                  <a:ext uri="{FF2B5EF4-FFF2-40B4-BE49-F238E27FC236}">
+                    <a16:creationId xmlns:a16="http://schemas.microsoft.com/office/drawing/2014/main" id="{380AAD23-4241-AE6A-9D7F-A6B7A5778D5E}"/>
+                  </a:ext>
+                </a:extLst>
+              </p:cNvPr>
+              <p:cNvSpPr txBox="1"/>
+              <p:nvPr/>
+            </p:nvSpPr>
+            <p:spPr>
+              <a:xfrm>
+                <a:off x="431478" y="183754"/>
+                <a:ext cx="1162453" cy="223157"/>
+              </a:xfrm>
+              <a:prstGeom prst="rect">
+                <a:avLst/>
+              </a:prstGeom>
+              <a:noFill/>
+            </p:spPr>
+            <p:txBody>
+              <a:bodyPr wrap="square">
+                <a:spAutoFit/>
+              </a:bodyPr>
+              <a:lstStyle/>
+              <a:p>
+                <a:pPr algn="ctr">
+                  <a:lnSpc>
+                    <a:spcPts val="1000"/>
+                  </a:lnSpc>
+                </a:pPr>
+                <a:r>
+                  <a:rPr lang="en-US" sz="1200" dirty="0">
+                    <a:solidFill>
+                      <a:schemeClr val="tx2">
+                        <a:lumMod val="75000"/>
+                        <a:lumOff val="25000"/>
+                      </a:schemeClr>
+                    </a:solidFill>
+                    <a:ea typeface="Helvetica Neue" panose="02000503000000020004" pitchFamily="2" charset="0"/>
+                    <a:cs typeface="Helvetica Neue" panose="02000503000000020004" pitchFamily="2" charset="0"/>
+                  </a:rPr>
+                  <a:t>Interannual (calendar-aligned) context</a:t>
+                </a:r>
+              </a:p>
+            </p:txBody>
+          </p:sp>
+          <p:cxnSp>
+            <p:nvCxnSpPr>
+              <p:cNvPr id="89" name="Straight Arrow Connector 88">
+                <a:extLst>
+                  <a:ext uri="{FF2B5EF4-FFF2-40B4-BE49-F238E27FC236}">
+                    <a16:creationId xmlns:a16="http://schemas.microsoft.com/office/drawing/2014/main" id="{F365A950-8347-CF1A-BD9B-CCE3CC511441}"/>
+                  </a:ext>
+                </a:extLst>
+              </p:cNvPr>
+              <p:cNvCxnSpPr>
+                <a:cxnSpLocks/>
+                <a:stCxn id="88" idx="2"/>
+              </p:cNvCxnSpPr>
+              <p:nvPr/>
+            </p:nvCxnSpPr>
+            <p:spPr>
+              <a:xfrm flipH="1">
+                <a:off x="996854" y="406911"/>
+                <a:ext cx="15851" cy="323151"/>
+              </a:xfrm>
+              <a:prstGeom prst="straightConnector1">
+                <a:avLst/>
+              </a:prstGeom>
+              <a:ln w="12700">
+                <a:solidFill>
+                  <a:schemeClr val="tx2">
+                    <a:lumMod val="75000"/>
+                    <a:lumOff val="25000"/>
+                  </a:schemeClr>
+                </a:solidFill>
+                <a:tailEnd type="triangle" w="sm" len="med"/>
+              </a:ln>
+            </p:spPr>
+            <p:style>
+              <a:lnRef idx="2">
+                <a:schemeClr val="accent1"/>
+              </a:lnRef>
+              <a:fillRef idx="0">
+                <a:schemeClr val="accent1"/>
+              </a:fillRef>
+              <a:effectRef idx="1">
+                <a:schemeClr val="accent1"/>
+              </a:effectRef>
+              <a:fontRef idx="minor">
+                <a:schemeClr val="tx1"/>
+              </a:fontRef>
+            </p:style>
+          </p:cxnSp>
+          <p:sp>
+            <p:nvSpPr>
+              <p:cNvPr id="90" name="TextBox 89">
+                <a:extLst>
+                  <a:ext uri="{FF2B5EF4-FFF2-40B4-BE49-F238E27FC236}">
+                    <a16:creationId xmlns:a16="http://schemas.microsoft.com/office/drawing/2014/main" id="{C7042475-6DD8-0BC0-A7F9-8B6BB6DADEF7}"/>
+                  </a:ext>
+                </a:extLst>
+              </p:cNvPr>
+              <p:cNvSpPr txBox="1"/>
+              <p:nvPr/>
+            </p:nvSpPr>
+            <p:spPr>
+              <a:xfrm>
+                <a:off x="315865" y="-4868"/>
+                <a:ext cx="1186948" cy="169785"/>
+              </a:xfrm>
+              <a:prstGeom prst="rect">
+                <a:avLst/>
+              </a:prstGeom>
+              <a:noFill/>
+            </p:spPr>
+            <p:txBody>
+              <a:bodyPr wrap="square">
+                <a:spAutoFit/>
+              </a:bodyPr>
+              <a:lstStyle/>
+              <a:p>
+                <a:pPr algn="ctr"/>
+                <a:r>
+                  <a:rPr lang="en-US" sz="1200" dirty="0">
+                    <a:ea typeface="Helvetica Neue" panose="02000503000000020004" pitchFamily="2" charset="0"/>
+                    <a:cs typeface="Helvetica Neue" panose="02000503000000020004" pitchFamily="2" charset="0"/>
+                  </a:rPr>
+                  <a:t>Historical states</a:t>
+                </a:r>
+              </a:p>
+            </p:txBody>
+          </p:sp>
+          <p:sp>
+            <p:nvSpPr>
+              <p:cNvPr id="91" name="TextBox 90">
+                <a:extLst>
+                  <a:ext uri="{FF2B5EF4-FFF2-40B4-BE49-F238E27FC236}">
+                    <a16:creationId xmlns:a16="http://schemas.microsoft.com/office/drawing/2014/main" id="{33EE8774-8A36-F3F1-7173-6DA9E497A5B2}"/>
+                  </a:ext>
+                </a:extLst>
+              </p:cNvPr>
+              <p:cNvSpPr txBox="1"/>
+              <p:nvPr/>
+            </p:nvSpPr>
+            <p:spPr>
+              <a:xfrm>
+                <a:off x="2445842" y="-12439"/>
+                <a:ext cx="926157" cy="169785"/>
+              </a:xfrm>
+              <a:prstGeom prst="rect">
+                <a:avLst/>
+              </a:prstGeom>
+              <a:noFill/>
+            </p:spPr>
+            <p:txBody>
+              <a:bodyPr wrap="square" rtlCol="0">
+                <a:spAutoFit/>
+              </a:bodyPr>
+              <a:lstStyle/>
+              <a:p>
+                <a:r>
+                  <a:rPr lang="en-US" sz="1200" dirty="0">
+                    <a:ea typeface="Helvetica Neue" panose="02000503000000020004" pitchFamily="2" charset="0"/>
+                    <a:cs typeface="Helvetica Neue" panose="02000503000000020004" pitchFamily="2" charset="0"/>
+                  </a:rPr>
+                  <a:t>Future states</a:t>
+                </a:r>
+              </a:p>
+            </p:txBody>
+          </p:sp>
+          <p:sp>
+            <p:nvSpPr>
+              <p:cNvPr id="92" name="Rectangle 91">
+                <a:extLst>
+                  <a:ext uri="{FF2B5EF4-FFF2-40B4-BE49-F238E27FC236}">
+                    <a16:creationId xmlns:a16="http://schemas.microsoft.com/office/drawing/2014/main" id="{E9F8C10D-99A4-63E8-5C6A-6F8B56CF2F6A}"/>
+                  </a:ext>
+                </a:extLst>
+              </p:cNvPr>
+              <p:cNvSpPr/>
+              <p:nvPr/>
+            </p:nvSpPr>
+            <p:spPr>
+              <a:xfrm>
+                <a:off x="432667" y="36459"/>
+                <a:ext cx="106474" cy="89366"/>
+              </a:xfrm>
+              <a:prstGeom prst="rect">
+                <a:avLst/>
+              </a:prstGeom>
+              <a:solidFill>
+                <a:schemeClr val="bg2"/>
+              </a:solidFill>
+              <a:ln>
+                <a:noFill/>
+              </a:ln>
+            </p:spPr>
+            <p:style>
+              <a:lnRef idx="2">
+                <a:schemeClr val="accent1">
+                  <a:shade val="15000"/>
+                </a:schemeClr>
+              </a:lnRef>
+              <a:fillRef idx="1">
+                <a:schemeClr val="accent1"/>
+              </a:fillRef>
+              <a:effectRef idx="0">
+                <a:schemeClr val="accent1"/>
+              </a:effectRef>
+              <a:fontRef idx="minor">
+                <a:schemeClr val="lt1"/>
+              </a:fontRef>
+            </p:style>
+            <p:txBody>
+              <a:bodyPr rtlCol="0" anchor="ctr"/>
+              <a:lstStyle/>
+              <a:p>
+                <a:pPr algn="ctr"/>
+                <a:endParaRPr lang="en-US" sz="1200">
+                  <a:ea typeface="Helvetica Neue" panose="02000503000000020004" pitchFamily="2" charset="0"/>
+                  <a:cs typeface="Helvetica Neue" panose="02000503000000020004" pitchFamily="2" charset="0"/>
+                </a:endParaRPr>
+              </a:p>
+            </p:txBody>
+          </p:sp>
+          <p:sp>
+            <p:nvSpPr>
+              <p:cNvPr id="93" name="Rectangle 92">
+                <a:extLst>
+                  <a:ext uri="{FF2B5EF4-FFF2-40B4-BE49-F238E27FC236}">
+                    <a16:creationId xmlns:a16="http://schemas.microsoft.com/office/drawing/2014/main" id="{61F2C2A0-1D85-50C0-CEA8-CA7B6BACC62C}"/>
+                  </a:ext>
+                </a:extLst>
+              </p:cNvPr>
+              <p:cNvSpPr/>
+              <p:nvPr/>
+            </p:nvSpPr>
+            <p:spPr>
+              <a:xfrm>
+                <a:off x="2354275" y="51930"/>
+                <a:ext cx="106474" cy="89366"/>
+              </a:xfrm>
+              <a:prstGeom prst="rect">
+                <a:avLst/>
+              </a:prstGeom>
+              <a:solidFill>
+                <a:schemeClr val="tx2">
+                  <a:lumMod val="10000"/>
+                  <a:lumOff val="90000"/>
+                </a:schemeClr>
+              </a:solidFill>
+              <a:ln>
+                <a:noFill/>
+              </a:ln>
+            </p:spPr>
+            <p:style>
+              <a:lnRef idx="2">
+                <a:schemeClr val="accent1">
+                  <a:shade val="15000"/>
+                </a:schemeClr>
+              </a:lnRef>
+              <a:fillRef idx="1">
+                <a:schemeClr val="accent1"/>
+              </a:fillRef>
+              <a:effectRef idx="0">
+                <a:schemeClr val="accent1"/>
+              </a:effectRef>
+              <a:fontRef idx="minor">
+                <a:schemeClr val="lt1"/>
+              </a:fontRef>
+            </p:style>
+            <p:txBody>
+              <a:bodyPr rtlCol="0" anchor="ctr"/>
+              <a:lstStyle/>
+              <a:p>
+                <a:pPr algn="ctr"/>
+                <a:endParaRPr lang="en-US" sz="1200">
+                  <a:ea typeface="Helvetica Neue" panose="02000503000000020004" pitchFamily="2" charset="0"/>
+                  <a:cs typeface="Helvetica Neue" panose="02000503000000020004" pitchFamily="2" charset="0"/>
+                </a:endParaRPr>
+              </a:p>
+            </p:txBody>
+          </p:sp>
+          <p:grpSp>
+            <p:nvGrpSpPr>
+              <p:cNvPr id="94" name="Group 93">
+                <a:extLst>
+                  <a:ext uri="{FF2B5EF4-FFF2-40B4-BE49-F238E27FC236}">
+                    <a16:creationId xmlns:a16="http://schemas.microsoft.com/office/drawing/2014/main" id="{DFA31EC1-939E-99E6-8F12-521FD90F476B}"/>
+                  </a:ext>
+                </a:extLst>
+              </p:cNvPr>
+              <p:cNvGrpSpPr/>
+              <p:nvPr/>
+            </p:nvGrpSpPr>
+            <p:grpSpPr>
+              <a:xfrm>
+                <a:off x="233567" y="1379897"/>
+                <a:ext cx="2951823" cy="255426"/>
+                <a:chOff x="290312" y="1631747"/>
+                <a:chExt cx="2951823" cy="329415"/>
+              </a:xfrm>
+            </p:grpSpPr>
+            <p:cxnSp>
+              <p:nvCxnSpPr>
+                <p:cNvPr id="95" name="Straight Connector 94">
+                  <a:extLst>
+                    <a:ext uri="{FF2B5EF4-FFF2-40B4-BE49-F238E27FC236}">
+                      <a16:creationId xmlns:a16="http://schemas.microsoft.com/office/drawing/2014/main" id="{06105AD8-815C-0904-FBFA-7487D626B87F}"/>
+                    </a:ext>
+                  </a:extLst>
+                </p:cNvPr>
+                <p:cNvCxnSpPr>
+                  <a:cxnSpLocks/>
+                </p:cNvCxnSpPr>
+                <p:nvPr/>
+              </p:nvCxnSpPr>
+              <p:spPr>
+                <a:xfrm>
+                  <a:off x="290312" y="1864328"/>
+                  <a:ext cx="2951823" cy="0"/>
+                </a:xfrm>
+                <a:prstGeom prst="line">
+                  <a:avLst/>
+                </a:prstGeom>
+                <a:ln w="9525">
+                  <a:headEnd type="none"/>
+                  <a:tailEnd type="triangle" w="sm" len="med"/>
+                </a:ln>
+              </p:spPr>
+              <p:style>
+                <a:lnRef idx="2">
+                  <a:schemeClr val="dk1"/>
+                </a:lnRef>
+                <a:fillRef idx="0">
+                  <a:schemeClr val="dk1"/>
+                </a:fillRef>
+                <a:effectRef idx="1">
+                  <a:schemeClr val="dk1"/>
+                </a:effectRef>
+                <a:fontRef idx="minor">
+                  <a:schemeClr val="tx1"/>
+                </a:fontRef>
+              </p:style>
+            </p:cxnSp>
+            <p:cxnSp>
+              <p:nvCxnSpPr>
+                <p:cNvPr id="96" name="Straight Connector 95">
+                  <a:extLst>
+                    <a:ext uri="{FF2B5EF4-FFF2-40B4-BE49-F238E27FC236}">
+                      <a16:creationId xmlns:a16="http://schemas.microsoft.com/office/drawing/2014/main" id="{008E0F31-5368-F1EC-4C8B-657B7DD4BD87}"/>
+                    </a:ext>
+                  </a:extLst>
+                </p:cNvPr>
+                <p:cNvCxnSpPr>
+                  <a:cxnSpLocks/>
+                </p:cNvCxnSpPr>
+                <p:nvPr/>
+              </p:nvCxnSpPr>
+              <p:spPr>
+                <a:xfrm flipV="1">
+                  <a:off x="564196" y="1704183"/>
+                  <a:ext cx="0" cy="256979"/>
+                </a:xfrm>
+                <a:prstGeom prst="line">
+                  <a:avLst/>
+                </a:prstGeom>
+                <a:ln w="9525"/>
+              </p:spPr>
+              <p:style>
+                <a:lnRef idx="2">
+                  <a:schemeClr val="dk1"/>
+                </a:lnRef>
+                <a:fillRef idx="0">
+                  <a:schemeClr val="dk1"/>
+                </a:fillRef>
+                <a:effectRef idx="1">
+                  <a:schemeClr val="dk1"/>
+                </a:effectRef>
+                <a:fontRef idx="minor">
+                  <a:schemeClr val="tx1"/>
+                </a:fontRef>
+              </p:style>
+            </p:cxnSp>
+            <p:cxnSp>
+              <p:nvCxnSpPr>
+                <p:cNvPr id="97" name="Straight Arrow Connector 96">
+                  <a:extLst>
+                    <a:ext uri="{FF2B5EF4-FFF2-40B4-BE49-F238E27FC236}">
+                      <a16:creationId xmlns:a16="http://schemas.microsoft.com/office/drawing/2014/main" id="{01E19AAF-512E-C812-6825-0C429998D5EB}"/>
+                    </a:ext>
+                  </a:extLst>
+                </p:cNvPr>
+                <p:cNvCxnSpPr>
+                  <a:cxnSpLocks/>
+                </p:cNvCxnSpPr>
+                <p:nvPr/>
+              </p:nvCxnSpPr>
+              <p:spPr>
+                <a:xfrm flipV="1">
+                  <a:off x="569220" y="1789005"/>
+                  <a:ext cx="645951" cy="0"/>
+                </a:xfrm>
+                <a:prstGeom prst="straightConnector1">
+                  <a:avLst/>
+                </a:prstGeom>
+                <a:ln w="9525">
+                  <a:headEnd type="triangle" w="sm" len="med"/>
+                  <a:tailEnd type="triangle" w="sm" len="med"/>
+                </a:ln>
+              </p:spPr>
+              <p:style>
+                <a:lnRef idx="2">
+                  <a:schemeClr val="dk1"/>
+                </a:lnRef>
+                <a:fillRef idx="0">
+                  <a:schemeClr val="dk1"/>
+                </a:fillRef>
+                <a:effectRef idx="1">
+                  <a:schemeClr val="dk1"/>
+                </a:effectRef>
+                <a:fontRef idx="minor">
+                  <a:schemeClr val="tx1"/>
+                </a:fontRef>
+              </p:style>
+            </p:cxnSp>
+            <p:cxnSp>
+              <p:nvCxnSpPr>
+                <p:cNvPr id="98" name="Straight Connector 97">
+                  <a:extLst>
+                    <a:ext uri="{FF2B5EF4-FFF2-40B4-BE49-F238E27FC236}">
+                      <a16:creationId xmlns:a16="http://schemas.microsoft.com/office/drawing/2014/main" id="{A79FCA4D-D5A6-7E0D-299E-9CC31971E7EE}"/>
+                    </a:ext>
+                  </a:extLst>
+                </p:cNvPr>
+                <p:cNvCxnSpPr>
+                  <a:cxnSpLocks/>
+                </p:cNvCxnSpPr>
+                <p:nvPr/>
+              </p:nvCxnSpPr>
+              <p:spPr>
+                <a:xfrm flipV="1">
+                  <a:off x="1208889" y="1704183"/>
+                  <a:ext cx="0" cy="256979"/>
+                </a:xfrm>
+                <a:prstGeom prst="line">
+                  <a:avLst/>
+                </a:prstGeom>
+                <a:ln w="9525"/>
+              </p:spPr>
+              <p:style>
+                <a:lnRef idx="2">
+                  <a:schemeClr val="dk1"/>
+                </a:lnRef>
+                <a:fillRef idx="0">
+                  <a:schemeClr val="dk1"/>
+                </a:fillRef>
+                <a:effectRef idx="1">
+                  <a:schemeClr val="dk1"/>
+                </a:effectRef>
+                <a:fontRef idx="minor">
+                  <a:schemeClr val="tx1"/>
+                </a:fontRef>
+              </p:style>
+            </p:cxnSp>
+            <p:cxnSp>
+              <p:nvCxnSpPr>
+                <p:cNvPr id="99" name="Straight Arrow Connector 98">
+                  <a:extLst>
+                    <a:ext uri="{FF2B5EF4-FFF2-40B4-BE49-F238E27FC236}">
+                      <a16:creationId xmlns:a16="http://schemas.microsoft.com/office/drawing/2014/main" id="{7FE5C5B3-F26A-548C-6792-F4D18D39E28E}"/>
+                    </a:ext>
+                  </a:extLst>
+                </p:cNvPr>
+                <p:cNvCxnSpPr>
+                  <a:cxnSpLocks/>
+                </p:cNvCxnSpPr>
+                <p:nvPr/>
+              </p:nvCxnSpPr>
+              <p:spPr>
+                <a:xfrm flipV="1">
+                  <a:off x="1207422" y="1789005"/>
+                  <a:ext cx="645951" cy="0"/>
+                </a:xfrm>
+                <a:prstGeom prst="straightConnector1">
+                  <a:avLst/>
+                </a:prstGeom>
+                <a:ln w="9525">
+                  <a:headEnd type="triangle" w="sm" len="med"/>
+                  <a:tailEnd type="triangle" w="sm" len="med"/>
+                </a:ln>
+              </p:spPr>
+              <p:style>
+                <a:lnRef idx="2">
+                  <a:schemeClr val="dk1"/>
+                </a:lnRef>
+                <a:fillRef idx="0">
+                  <a:schemeClr val="dk1"/>
+                </a:fillRef>
+                <a:effectRef idx="1">
+                  <a:schemeClr val="dk1"/>
+                </a:effectRef>
+                <a:fontRef idx="minor">
+                  <a:schemeClr val="tx1"/>
+                </a:fontRef>
+              </p:style>
+            </p:cxnSp>
+            <p:cxnSp>
+              <p:nvCxnSpPr>
+                <p:cNvPr id="100" name="Straight Connector 99">
+                  <a:extLst>
+                    <a:ext uri="{FF2B5EF4-FFF2-40B4-BE49-F238E27FC236}">
+                      <a16:creationId xmlns:a16="http://schemas.microsoft.com/office/drawing/2014/main" id="{977CF21A-1C9D-270C-AAEA-39690614D401}"/>
+                    </a:ext>
+                  </a:extLst>
+                </p:cNvPr>
+                <p:cNvCxnSpPr>
+                  <a:cxnSpLocks/>
+                </p:cNvCxnSpPr>
+                <p:nvPr/>
+              </p:nvCxnSpPr>
+              <p:spPr>
+                <a:xfrm flipV="1">
+                  <a:off x="1845624" y="1704183"/>
+                  <a:ext cx="0" cy="256979"/>
+                </a:xfrm>
+                <a:prstGeom prst="line">
+                  <a:avLst/>
+                </a:prstGeom>
+                <a:ln w="9525"/>
+              </p:spPr>
+              <p:style>
+                <a:lnRef idx="2">
+                  <a:schemeClr val="dk1"/>
+                </a:lnRef>
+                <a:fillRef idx="0">
+                  <a:schemeClr val="dk1"/>
+                </a:fillRef>
+                <a:effectRef idx="1">
+                  <a:schemeClr val="dk1"/>
+                </a:effectRef>
+                <a:fontRef idx="minor">
+                  <a:schemeClr val="tx1"/>
+                </a:fontRef>
+              </p:style>
+            </p:cxnSp>
+            <p:cxnSp>
+              <p:nvCxnSpPr>
+                <p:cNvPr id="101" name="Straight Arrow Connector 100">
+                  <a:extLst>
+                    <a:ext uri="{FF2B5EF4-FFF2-40B4-BE49-F238E27FC236}">
+                      <a16:creationId xmlns:a16="http://schemas.microsoft.com/office/drawing/2014/main" id="{48C9277A-E7C9-7F2F-75C9-64A5F81E044C}"/>
+                    </a:ext>
+                  </a:extLst>
+                </p:cNvPr>
+                <p:cNvCxnSpPr>
+                  <a:cxnSpLocks/>
+                </p:cNvCxnSpPr>
+                <p:nvPr/>
+              </p:nvCxnSpPr>
+              <p:spPr>
+                <a:xfrm flipV="1">
+                  <a:off x="1845624" y="1789005"/>
+                  <a:ext cx="645951" cy="0"/>
+                </a:xfrm>
+                <a:prstGeom prst="straightConnector1">
+                  <a:avLst/>
+                </a:prstGeom>
+                <a:ln w="9525">
+                  <a:headEnd type="triangle" w="sm" len="med"/>
+                  <a:tailEnd type="triangle" w="sm" len="med"/>
+                </a:ln>
+              </p:spPr>
+              <p:style>
+                <a:lnRef idx="2">
+                  <a:schemeClr val="dk1"/>
+                </a:lnRef>
+                <a:fillRef idx="0">
+                  <a:schemeClr val="dk1"/>
+                </a:fillRef>
+                <a:effectRef idx="1">
+                  <a:schemeClr val="dk1"/>
+                </a:effectRef>
+                <a:fontRef idx="minor">
+                  <a:schemeClr val="tx1"/>
+                </a:fontRef>
+              </p:style>
+            </p:cxnSp>
+            <p:cxnSp>
+              <p:nvCxnSpPr>
+                <p:cNvPr id="102" name="Straight Connector 101">
+                  <a:extLst>
+                    <a:ext uri="{FF2B5EF4-FFF2-40B4-BE49-F238E27FC236}">
+                      <a16:creationId xmlns:a16="http://schemas.microsoft.com/office/drawing/2014/main" id="{78D98340-8390-BC83-9B51-43C5E56F151D}"/>
+                    </a:ext>
+                  </a:extLst>
+                </p:cNvPr>
+                <p:cNvCxnSpPr>
+                  <a:cxnSpLocks/>
+                </p:cNvCxnSpPr>
+                <p:nvPr/>
+              </p:nvCxnSpPr>
+              <p:spPr>
+                <a:xfrm flipV="1">
+                  <a:off x="2483826" y="1704183"/>
+                  <a:ext cx="0" cy="256979"/>
+                </a:xfrm>
+                <a:prstGeom prst="line">
+                  <a:avLst/>
+                </a:prstGeom>
+                <a:ln w="9525"/>
+              </p:spPr>
+              <p:style>
+                <a:lnRef idx="2">
+                  <a:schemeClr val="dk1"/>
+                </a:lnRef>
+                <a:fillRef idx="0">
+                  <a:schemeClr val="dk1"/>
+                </a:fillRef>
+                <a:effectRef idx="1">
+                  <a:schemeClr val="dk1"/>
+                </a:effectRef>
+                <a:fontRef idx="minor">
+                  <a:schemeClr val="tx1"/>
+                </a:fontRef>
+              </p:style>
+            </p:cxnSp>
+            <mc:AlternateContent xmlns:mc="http://schemas.openxmlformats.org/markup-compatibility/2006">
+              <mc:Choice xmlns:a14="http://schemas.microsoft.com/office/drawing/2010/main" Requires="a14">
+                <p:sp>
+                  <p:nvSpPr>
+                    <p:cNvPr id="103" name="TextBox 102">
+                      <a:extLst>
+                        <a:ext uri="{FF2B5EF4-FFF2-40B4-BE49-F238E27FC236}">
+                          <a16:creationId xmlns:a16="http://schemas.microsoft.com/office/drawing/2014/main" id="{11612FD6-0592-C8BD-13FD-7184DE840D0A}"/>
+                        </a:ext>
+                      </a:extLst>
+                    </p:cNvPr>
+                    <p:cNvSpPr txBox="1"/>
+                    <p:nvPr/>
+                  </p:nvSpPr>
+                  <p:spPr>
+                    <a:xfrm>
+                      <a:off x="726047" y="1631747"/>
+                      <a:ext cx="401067" cy="145978"/>
+                    </a:xfrm>
+                    <a:prstGeom prst="rect">
+                      <a:avLst/>
+                    </a:prstGeom>
+                    <a:noFill/>
+                  </p:spPr>
+                  <p:txBody>
+                    <a:bodyPr wrap="square" lIns="0" tIns="0" rIns="0" bIns="0" rtlCol="0">
+                      <a:spAutoFit/>
+                    </a:bodyPr>
+                    <a:lstStyle/>
+                    <a:p>
+                      <a14:m>
+                        <m:oMath xmlns:m="http://schemas.openxmlformats.org/officeDocument/2006/math">
+                          <m:r>
+                            <a:rPr lang="en-US" sz="1200" i="1">
+                              <a:latin typeface="Cambria Math" panose="02040503050406030204" pitchFamily="18" charset="0"/>
+                              <a:ea typeface="Cambria Math" panose="02040503050406030204" pitchFamily="18" charset="0"/>
+                            </a:rPr>
+                            <m:t>△</m:t>
+                          </m:r>
+                        </m:oMath>
+                      </a14:m>
+                      <a:r>
+                        <a:rPr lang="en-US" sz="1200" dirty="0">
+                          <a:ea typeface="Helvetica Neue" panose="02000503000000020004" pitchFamily="2" charset="0"/>
+                          <a:cs typeface="Helvetica Neue" panose="02000503000000020004" pitchFamily="2" charset="0"/>
+                        </a:rPr>
+                        <a:t>year</a:t>
+                      </a:r>
+                    </a:p>
+                  </p:txBody>
+                </p:sp>
+              </mc:Choice>
+              <mc:Fallback>
+                <p:sp>
+                  <p:nvSpPr>
+                    <p:cNvPr id="103" name="TextBox 102">
+                      <a:extLst>
+                        <a:ext uri="{FF2B5EF4-FFF2-40B4-BE49-F238E27FC236}">
+                          <a16:creationId xmlns:a16="http://schemas.microsoft.com/office/drawing/2014/main" id="{11612FD6-0592-C8BD-13FD-7184DE840D0A}"/>
+                        </a:ext>
+                      </a:extLst>
+                    </p:cNvPr>
+                    <p:cNvSpPr txBox="1">
+                      <a:spLocks noRot="1" noChangeAspect="1" noMove="1" noResize="1" noEditPoints="1" noAdjustHandles="1" noChangeArrowheads="1" noChangeShapeType="1" noTextEdit="1"/>
+                    </p:cNvSpPr>
+                    <p:nvPr/>
+                  </p:nvSpPr>
+                  <p:spPr>
+                    <a:xfrm>
+                      <a:off x="726047" y="1631747"/>
+                      <a:ext cx="401067" cy="145978"/>
+                    </a:xfrm>
+                    <a:prstGeom prst="rect">
+                      <a:avLst/>
+                    </a:prstGeom>
+                    <a:blipFill>
+                      <a:blip r:embed="rId4"/>
+                      <a:stretch>
+                        <a:fillRect l="-7547" t="-25000" b="-37500"/>
+                      </a:stretch>
+                    </a:blipFill>
+                  </p:spPr>
+                  <p:txBody>
+                    <a:bodyPr/>
+                    <a:lstStyle/>
+                    <a:p>
+                      <a:r>
+                        <a:rPr lang="en-US">
+                          <a:noFill/>
+                        </a:rPr>
+                        <a:t> </a:t>
+                      </a:r>
+                    </a:p>
+                  </p:txBody>
+                </p:sp>
+              </mc:Fallback>
+            </mc:AlternateContent>
+            <mc:AlternateContent xmlns:mc="http://schemas.openxmlformats.org/markup-compatibility/2006">
+              <mc:Choice xmlns:a14="http://schemas.microsoft.com/office/drawing/2010/main" Requires="a14">
+                <p:sp>
+                  <p:nvSpPr>
+                    <p:cNvPr id="104" name="TextBox 103">
+                      <a:extLst>
+                        <a:ext uri="{FF2B5EF4-FFF2-40B4-BE49-F238E27FC236}">
+                          <a16:creationId xmlns:a16="http://schemas.microsoft.com/office/drawing/2014/main" id="{B4E8EC7A-8BB1-4C16-51CD-56F4B80E8A3B}"/>
+                        </a:ext>
+                      </a:extLst>
+                    </p:cNvPr>
+                    <p:cNvSpPr txBox="1"/>
+                    <p:nvPr/>
+                  </p:nvSpPr>
+                  <p:spPr>
+                    <a:xfrm>
+                      <a:off x="1420681" y="1634291"/>
+                      <a:ext cx="401067" cy="145978"/>
+                    </a:xfrm>
+                    <a:prstGeom prst="rect">
+                      <a:avLst/>
+                    </a:prstGeom>
+                    <a:noFill/>
+                  </p:spPr>
+                  <p:txBody>
+                    <a:bodyPr wrap="square" lIns="0" tIns="0" rIns="0" bIns="0" rtlCol="0">
+                      <a:spAutoFit/>
+                    </a:bodyPr>
+                    <a:lstStyle/>
+                    <a:p>
+                      <a14:m>
+                        <m:oMath xmlns:m="http://schemas.openxmlformats.org/officeDocument/2006/math">
+                          <m:r>
+                            <a:rPr lang="en-US" sz="1200" i="1">
+                              <a:latin typeface="Cambria Math" panose="02040503050406030204" pitchFamily="18" charset="0"/>
+                              <a:ea typeface="Cambria Math" panose="02040503050406030204" pitchFamily="18" charset="0"/>
+                            </a:rPr>
+                            <m:t>△</m:t>
+                          </m:r>
+                        </m:oMath>
+                      </a14:m>
+                      <a:r>
+                        <a:rPr lang="en-US" sz="1200" dirty="0">
+                          <a:ea typeface="Helvetica Neue" panose="02000503000000020004" pitchFamily="2" charset="0"/>
+                          <a:cs typeface="Helvetica Neue" panose="02000503000000020004" pitchFamily="2" charset="0"/>
+                        </a:rPr>
+                        <a:t>year</a:t>
+                      </a:r>
+                    </a:p>
+                  </p:txBody>
+                </p:sp>
+              </mc:Choice>
+              <mc:Fallback>
+                <p:sp>
+                  <p:nvSpPr>
+                    <p:cNvPr id="104" name="TextBox 103">
+                      <a:extLst>
+                        <a:ext uri="{FF2B5EF4-FFF2-40B4-BE49-F238E27FC236}">
+                          <a16:creationId xmlns:a16="http://schemas.microsoft.com/office/drawing/2014/main" id="{B4E8EC7A-8BB1-4C16-51CD-56F4B80E8A3B}"/>
+                        </a:ext>
+                      </a:extLst>
+                    </p:cNvPr>
+                    <p:cNvSpPr txBox="1">
+                      <a:spLocks noRot="1" noChangeAspect="1" noMove="1" noResize="1" noEditPoints="1" noAdjustHandles="1" noChangeArrowheads="1" noChangeShapeType="1" noTextEdit="1"/>
+                    </p:cNvSpPr>
+                    <p:nvPr/>
+                  </p:nvSpPr>
+                  <p:spPr>
+                    <a:xfrm>
+                      <a:off x="1420681" y="1634291"/>
+                      <a:ext cx="401067" cy="145978"/>
+                    </a:xfrm>
+                    <a:prstGeom prst="rect">
+                      <a:avLst/>
+                    </a:prstGeom>
+                    <a:blipFill>
+                      <a:blip r:embed="rId5"/>
+                      <a:stretch>
+                        <a:fillRect l="-7547" t="-18750" b="-43750"/>
+                      </a:stretch>
+                    </a:blipFill>
+                  </p:spPr>
+                  <p:txBody>
+                    <a:bodyPr/>
+                    <a:lstStyle/>
+                    <a:p>
+                      <a:r>
+                        <a:rPr lang="en-US">
+                          <a:noFill/>
+                        </a:rPr>
+                        <a:t> </a:t>
+                      </a:r>
+                    </a:p>
+                  </p:txBody>
+                </p:sp>
+              </mc:Fallback>
+            </mc:AlternateContent>
+            <mc:AlternateContent xmlns:mc="http://schemas.openxmlformats.org/markup-compatibility/2006">
+              <mc:Choice xmlns:a14="http://schemas.microsoft.com/office/drawing/2010/main" Requires="a14">
+                <p:sp>
+                  <p:nvSpPr>
+                    <p:cNvPr id="105" name="TextBox 104">
+                      <a:extLst>
+                        <a:ext uri="{FF2B5EF4-FFF2-40B4-BE49-F238E27FC236}">
+                          <a16:creationId xmlns:a16="http://schemas.microsoft.com/office/drawing/2014/main" id="{BC2581DC-E5DA-610D-0123-7A9C7EE3D8CD}"/>
+                        </a:ext>
+                      </a:extLst>
+                    </p:cNvPr>
+                    <p:cNvSpPr txBox="1"/>
+                    <p:nvPr/>
+                  </p:nvSpPr>
+                  <p:spPr>
+                    <a:xfrm>
+                      <a:off x="2046300" y="1634571"/>
+                      <a:ext cx="401067" cy="145978"/>
+                    </a:xfrm>
+                    <a:prstGeom prst="rect">
+                      <a:avLst/>
+                    </a:prstGeom>
+                    <a:noFill/>
+                  </p:spPr>
+                  <p:txBody>
+                    <a:bodyPr wrap="square" lIns="0" tIns="0" rIns="0" bIns="0" rtlCol="0">
+                      <a:spAutoFit/>
+                    </a:bodyPr>
+                    <a:lstStyle/>
+                    <a:p>
+                      <a14:m>
+                        <m:oMath xmlns:m="http://schemas.openxmlformats.org/officeDocument/2006/math">
+                          <m:r>
+                            <a:rPr lang="en-US" sz="1200" i="1">
+                              <a:latin typeface="Cambria Math" panose="02040503050406030204" pitchFamily="18" charset="0"/>
+                              <a:ea typeface="Cambria Math" panose="02040503050406030204" pitchFamily="18" charset="0"/>
+                            </a:rPr>
+                            <m:t>△</m:t>
+                          </m:r>
+                        </m:oMath>
+                      </a14:m>
+                      <a:r>
+                        <a:rPr lang="en-US" sz="1200" dirty="0">
+                          <a:ea typeface="Helvetica Neue" panose="02000503000000020004" pitchFamily="2" charset="0"/>
+                          <a:cs typeface="Helvetica Neue" panose="02000503000000020004" pitchFamily="2" charset="0"/>
+                        </a:rPr>
+                        <a:t>year</a:t>
+                      </a:r>
+                    </a:p>
+                  </p:txBody>
+                </p:sp>
+              </mc:Choice>
+              <mc:Fallback>
+                <p:sp>
+                  <p:nvSpPr>
+                    <p:cNvPr id="105" name="TextBox 104">
+                      <a:extLst>
+                        <a:ext uri="{FF2B5EF4-FFF2-40B4-BE49-F238E27FC236}">
+                          <a16:creationId xmlns:a16="http://schemas.microsoft.com/office/drawing/2014/main" id="{BC2581DC-E5DA-610D-0123-7A9C7EE3D8CD}"/>
+                        </a:ext>
+                      </a:extLst>
+                    </p:cNvPr>
+                    <p:cNvSpPr txBox="1">
+                      <a:spLocks noRot="1" noChangeAspect="1" noMove="1" noResize="1" noEditPoints="1" noAdjustHandles="1" noChangeArrowheads="1" noChangeShapeType="1" noTextEdit="1"/>
+                    </p:cNvSpPr>
+                    <p:nvPr/>
+                  </p:nvSpPr>
+                  <p:spPr>
+                    <a:xfrm>
+                      <a:off x="2046300" y="1634571"/>
+                      <a:ext cx="401067" cy="145978"/>
+                    </a:xfrm>
+                    <a:prstGeom prst="rect">
+                      <a:avLst/>
+                    </a:prstGeom>
+                    <a:blipFill>
+                      <a:blip r:embed="rId6"/>
+                      <a:stretch>
+                        <a:fillRect l="-7692" t="-26667" b="-46667"/>
+                      </a:stretch>
+                    </a:blipFill>
+                  </p:spPr>
+                  <p:txBody>
+                    <a:bodyPr/>
+                    <a:lstStyle/>
+                    <a:p>
+                      <a:r>
+                        <a:rPr lang="en-US">
+                          <a:noFill/>
+                        </a:rPr>
+                        <a:t> </a:t>
+                      </a:r>
+                    </a:p>
+                  </p:txBody>
+                </p:sp>
+              </mc:Fallback>
+            </mc:AlternateContent>
+            <p:cxnSp>
+              <p:nvCxnSpPr>
+                <p:cNvPr id="106" name="Straight Connector 105">
+                  <a:extLst>
+                    <a:ext uri="{FF2B5EF4-FFF2-40B4-BE49-F238E27FC236}">
+                      <a16:creationId xmlns:a16="http://schemas.microsoft.com/office/drawing/2014/main" id="{55CD6DDA-6022-86BE-74A9-F858C8FA1496}"/>
+                    </a:ext>
+                  </a:extLst>
+                </p:cNvPr>
+                <p:cNvCxnSpPr>
+                  <a:cxnSpLocks/>
+                </p:cNvCxnSpPr>
+                <p:nvPr/>
+              </p:nvCxnSpPr>
+              <p:spPr>
+                <a:xfrm flipV="1">
+                  <a:off x="2406734" y="1832672"/>
+                  <a:ext cx="0" cy="126878"/>
+                </a:xfrm>
+                <a:prstGeom prst="line">
+                  <a:avLst/>
+                </a:prstGeom>
+                <a:ln w="9525"/>
+              </p:spPr>
+              <p:style>
+                <a:lnRef idx="2">
+                  <a:schemeClr val="dk1"/>
+                </a:lnRef>
+                <a:fillRef idx="0">
+                  <a:schemeClr val="dk1"/>
+                </a:fillRef>
+                <a:effectRef idx="1">
+                  <a:schemeClr val="dk1"/>
+                </a:effectRef>
+                <a:fontRef idx="minor">
+                  <a:schemeClr val="tx1"/>
+                </a:fontRef>
+              </p:style>
+            </p:cxnSp>
+            <p:cxnSp>
+              <p:nvCxnSpPr>
+                <p:cNvPr id="107" name="Straight Arrow Connector 106">
+                  <a:extLst>
+                    <a:ext uri="{FF2B5EF4-FFF2-40B4-BE49-F238E27FC236}">
+                      <a16:creationId xmlns:a16="http://schemas.microsoft.com/office/drawing/2014/main" id="{88E891F3-8A5F-2912-C719-FE14438FDED2}"/>
+                    </a:ext>
+                  </a:extLst>
+                </p:cNvPr>
+                <p:cNvCxnSpPr>
+                  <a:cxnSpLocks/>
+                </p:cNvCxnSpPr>
+                <p:nvPr/>
+              </p:nvCxnSpPr>
+              <p:spPr>
+                <a:xfrm>
+                  <a:off x="2196182" y="1915285"/>
+                  <a:ext cx="206167" cy="0"/>
+                </a:xfrm>
+                <a:prstGeom prst="straightConnector1">
+                  <a:avLst/>
+                </a:prstGeom>
+                <a:ln w="9525">
+                  <a:headEnd type="none"/>
+                  <a:tailEnd type="triangle" w="sm" len="med"/>
+                </a:ln>
+              </p:spPr>
+              <p:style>
+                <a:lnRef idx="2">
+                  <a:schemeClr val="dk1"/>
+                </a:lnRef>
+                <a:fillRef idx="0">
+                  <a:schemeClr val="dk1"/>
+                </a:fillRef>
+                <a:effectRef idx="1">
+                  <a:schemeClr val="dk1"/>
+                </a:effectRef>
+                <a:fontRef idx="minor">
+                  <a:schemeClr val="tx1"/>
+                </a:fontRef>
+              </p:style>
+            </p:cxnSp>
+            <p:cxnSp>
+              <p:nvCxnSpPr>
+                <p:cNvPr id="108" name="Straight Arrow Connector 107">
+                  <a:extLst>
+                    <a:ext uri="{FF2B5EF4-FFF2-40B4-BE49-F238E27FC236}">
+                      <a16:creationId xmlns:a16="http://schemas.microsoft.com/office/drawing/2014/main" id="{E0CFB3F4-5BCB-30CD-9915-D8832B5A3F89}"/>
+                    </a:ext>
+                  </a:extLst>
+                </p:cNvPr>
+                <p:cNvCxnSpPr>
+                  <a:cxnSpLocks/>
+                </p:cNvCxnSpPr>
+                <p:nvPr/>
+              </p:nvCxnSpPr>
+              <p:spPr>
+                <a:xfrm flipH="1">
+                  <a:off x="2486929" y="1915285"/>
+                  <a:ext cx="206167" cy="0"/>
+                </a:xfrm>
+                <a:prstGeom prst="straightConnector1">
+                  <a:avLst/>
+                </a:prstGeom>
+                <a:ln w="9525">
+                  <a:headEnd type="none"/>
+                  <a:tailEnd type="triangle" w="sm" len="med"/>
+                </a:ln>
+              </p:spPr>
+              <p:style>
+                <a:lnRef idx="2">
+                  <a:schemeClr val="dk1"/>
+                </a:lnRef>
+                <a:fillRef idx="0">
+                  <a:schemeClr val="dk1"/>
+                </a:fillRef>
+                <a:effectRef idx="1">
+                  <a:schemeClr val="dk1"/>
+                </a:effectRef>
+                <a:fontRef idx="minor">
+                  <a:schemeClr val="tx1"/>
+                </a:fontRef>
+              </p:style>
+            </p:cxnSp>
+          </p:grpSp>
+          <p:sp>
+            <p:nvSpPr>
+              <p:cNvPr id="109" name="TextBox 108">
+                <a:extLst>
+                  <a:ext uri="{FF2B5EF4-FFF2-40B4-BE49-F238E27FC236}">
+                    <a16:creationId xmlns:a16="http://schemas.microsoft.com/office/drawing/2014/main" id="{4D9B1235-6A4D-DCE3-A474-AB99A23936C7}"/>
+                  </a:ext>
+                </a:extLst>
+              </p:cNvPr>
+              <p:cNvSpPr txBox="1"/>
+              <p:nvPr/>
+            </p:nvSpPr>
+            <p:spPr>
+              <a:xfrm>
+                <a:off x="2278881" y="1577897"/>
+                <a:ext cx="340060" cy="169785"/>
+              </a:xfrm>
+              <a:prstGeom prst="rect">
+                <a:avLst/>
+              </a:prstGeom>
+              <a:noFill/>
+            </p:spPr>
+            <p:txBody>
+              <a:bodyPr wrap="square">
+                <a:spAutoFit/>
+              </a:bodyPr>
+              <a:lstStyle/>
+              <a:p>
+                <a:r>
+                  <a:rPr lang="el-GR" sz="1200" i="1" dirty="0">
+                    <a:ea typeface="Helvetica Neue" panose="02000503000000020004" pitchFamily="2" charset="0"/>
+                    <a:cs typeface="Helvetica Neue" panose="02000503000000020004" pitchFamily="2" charset="0"/>
+                  </a:rPr>
+                  <a:t>τ</a:t>
+                </a:r>
+                <a:endParaRPr lang="en-US" sz="1200" dirty="0">
+                  <a:ea typeface="Helvetica Neue" panose="02000503000000020004" pitchFamily="2" charset="0"/>
+                  <a:cs typeface="Helvetica Neue" panose="02000503000000020004" pitchFamily="2" charset="0"/>
+                </a:endParaRPr>
+              </a:p>
+            </p:txBody>
+          </p:sp>
+          <p:cxnSp>
+            <p:nvCxnSpPr>
+              <p:cNvPr id="110" name="Straight Connector 109">
+                <a:extLst>
+                  <a:ext uri="{FF2B5EF4-FFF2-40B4-BE49-F238E27FC236}">
+                    <a16:creationId xmlns:a16="http://schemas.microsoft.com/office/drawing/2014/main" id="{5D9E4C6E-36C6-3136-94A0-7341806FAFE5}"/>
+                  </a:ext>
+                </a:extLst>
+              </p:cNvPr>
+              <p:cNvCxnSpPr>
+                <a:cxnSpLocks/>
+              </p:cNvCxnSpPr>
+              <p:nvPr/>
+            </p:nvCxnSpPr>
+            <p:spPr>
+              <a:xfrm>
+                <a:off x="2347806" y="1014935"/>
+                <a:ext cx="0" cy="560738"/>
+              </a:xfrm>
+              <a:prstGeom prst="line">
+                <a:avLst/>
+              </a:prstGeom>
+              <a:ln w="9525">
+                <a:solidFill>
+                  <a:schemeClr val="tx1"/>
+                </a:solidFill>
+                <a:prstDash val="sysDash"/>
+              </a:ln>
+            </p:spPr>
+            <p:style>
+              <a:lnRef idx="2">
+                <a:schemeClr val="accent1"/>
+              </a:lnRef>
+              <a:fillRef idx="0">
+                <a:schemeClr val="accent1"/>
+              </a:fillRef>
+              <a:effectRef idx="1">
+                <a:schemeClr val="accent1"/>
+              </a:effectRef>
+              <a:fontRef idx="minor">
+                <a:schemeClr val="tx1"/>
+              </a:fontRef>
+            </p:style>
+          </p:cxnSp>
+          <p:cxnSp>
+            <p:nvCxnSpPr>
+              <p:cNvPr id="111" name="Straight Connector 110">
+                <a:extLst>
+                  <a:ext uri="{FF2B5EF4-FFF2-40B4-BE49-F238E27FC236}">
+                    <a16:creationId xmlns:a16="http://schemas.microsoft.com/office/drawing/2014/main" id="{071A34D1-7FC1-70B0-02EE-AF2E2A393F4D}"/>
+                  </a:ext>
+                </a:extLst>
+              </p:cNvPr>
+              <p:cNvCxnSpPr>
+                <a:cxnSpLocks/>
+                <a:stCxn id="68" idx="7"/>
+              </p:cNvCxnSpPr>
+              <p:nvPr/>
+            </p:nvCxnSpPr>
+            <p:spPr>
+              <a:xfrm flipV="1">
+                <a:off x="2514643" y="418661"/>
+                <a:ext cx="189654" cy="50459"/>
+              </a:xfrm>
+              <a:prstGeom prst="line">
+                <a:avLst/>
+              </a:prstGeom>
+              <a:solidFill>
+                <a:schemeClr val="accent5">
+                  <a:lumMod val="20000"/>
+                  <a:lumOff val="80000"/>
+                </a:schemeClr>
+              </a:solidFill>
+              <a:ln w="9525">
+                <a:solidFill>
+                  <a:schemeClr val="tx1">
+                    <a:lumMod val="50000"/>
+                    <a:lumOff val="50000"/>
+                  </a:schemeClr>
+                </a:solidFill>
+                <a:prstDash val="sysDash"/>
+              </a:ln>
+            </p:spPr>
+            <p:style>
+              <a:lnRef idx="2">
+                <a:schemeClr val="accent1"/>
+              </a:lnRef>
+              <a:fillRef idx="0">
+                <a:schemeClr val="accent1"/>
+              </a:fillRef>
+              <a:effectRef idx="1">
+                <a:schemeClr val="accent1"/>
+              </a:effectRef>
+              <a:fontRef idx="minor">
+                <a:schemeClr val="tx1"/>
+              </a:fontRef>
+            </p:style>
+          </p:cxnSp>
+          <p:cxnSp>
+            <p:nvCxnSpPr>
+              <p:cNvPr id="112" name="Straight Arrow Connector 111">
+                <a:extLst>
+                  <a:ext uri="{FF2B5EF4-FFF2-40B4-BE49-F238E27FC236}">
+                    <a16:creationId xmlns:a16="http://schemas.microsoft.com/office/drawing/2014/main" id="{96FE8FBD-C7D5-4102-FAA9-59828F138B6A}"/>
+                  </a:ext>
+                </a:extLst>
+              </p:cNvPr>
+              <p:cNvCxnSpPr>
+                <a:cxnSpLocks/>
+              </p:cNvCxnSpPr>
+              <p:nvPr/>
+            </p:nvCxnSpPr>
+            <p:spPr>
+              <a:xfrm flipH="1" flipV="1">
+                <a:off x="2324771" y="1132344"/>
+                <a:ext cx="214091" cy="94404"/>
+              </a:xfrm>
+              <a:prstGeom prst="straightConnector1">
+                <a:avLst/>
+              </a:prstGeom>
+              <a:ln w="12700">
+                <a:solidFill>
+                  <a:srgbClr val="C00000"/>
+                </a:solidFill>
+                <a:tailEnd type="triangle" w="sm" len="med"/>
+              </a:ln>
+            </p:spPr>
+            <p:style>
+              <a:lnRef idx="2">
+                <a:schemeClr val="accent1"/>
+              </a:lnRef>
+              <a:fillRef idx="0">
+                <a:schemeClr val="accent1"/>
+              </a:fillRef>
+              <a:effectRef idx="1">
+                <a:schemeClr val="accent1"/>
+              </a:effectRef>
+              <a:fontRef idx="minor">
+                <a:schemeClr val="tx1"/>
+              </a:fontRef>
+            </p:style>
+          </p:cxnSp>
+          <p:sp>
+            <p:nvSpPr>
+              <p:cNvPr id="113" name="Rectangle 112">
+                <a:extLst>
+                  <a:ext uri="{FF2B5EF4-FFF2-40B4-BE49-F238E27FC236}">
+                    <a16:creationId xmlns:a16="http://schemas.microsoft.com/office/drawing/2014/main" id="{C4FA4C6F-F5CF-4BF8-FFB4-1F27D95BDBD9}"/>
+                  </a:ext>
+                </a:extLst>
+              </p:cNvPr>
+              <p:cNvSpPr/>
+              <p:nvPr/>
+            </p:nvSpPr>
+            <p:spPr>
+              <a:xfrm>
+                <a:off x="2698368" y="883177"/>
+                <a:ext cx="316652" cy="403238"/>
+              </a:xfrm>
+              <a:prstGeom prst="rect">
+                <a:avLst/>
+              </a:prstGeom>
+              <a:solidFill>
+                <a:schemeClr val="tx2">
+                  <a:lumMod val="10000"/>
+                  <a:lumOff val="90000"/>
+                </a:schemeClr>
+              </a:solidFill>
+              <a:ln>
+                <a:noFill/>
+              </a:ln>
+            </p:spPr>
+            <p:style>
+              <a:lnRef idx="2">
+                <a:schemeClr val="accent1">
+                  <a:shade val="15000"/>
+                </a:schemeClr>
+              </a:lnRef>
+              <a:fillRef idx="1">
+                <a:schemeClr val="accent1"/>
+              </a:fillRef>
+              <a:effectRef idx="0">
+                <a:schemeClr val="accent1"/>
+              </a:effectRef>
+              <a:fontRef idx="minor">
+                <a:schemeClr val="lt1"/>
+              </a:fontRef>
+            </p:style>
+            <p:txBody>
+              <a:bodyPr rtlCol="0" anchor="ctr"/>
+              <a:lstStyle/>
+              <a:p>
+                <a:pPr algn="ctr"/>
+                <a:endParaRPr lang="en-US" sz="1200">
+                  <a:ea typeface="Helvetica Neue" panose="02000503000000020004" pitchFamily="2" charset="0"/>
+                  <a:cs typeface="Helvetica Neue" panose="02000503000000020004" pitchFamily="2" charset="0"/>
+                </a:endParaRPr>
+              </a:p>
+            </p:txBody>
+          </p:sp>
+          <p:sp>
+            <p:nvSpPr>
+              <p:cNvPr id="114" name="TextBox 113">
+                <a:extLst>
+                  <a:ext uri="{FF2B5EF4-FFF2-40B4-BE49-F238E27FC236}">
+                    <a16:creationId xmlns:a16="http://schemas.microsoft.com/office/drawing/2014/main" id="{3D80C715-6B57-50FE-214B-76BE2944BE9B}"/>
+                  </a:ext>
+                </a:extLst>
+              </p:cNvPr>
+              <p:cNvSpPr txBox="1"/>
+              <p:nvPr/>
+            </p:nvSpPr>
+            <p:spPr>
+              <a:xfrm>
+                <a:off x="2353092" y="1108238"/>
+                <a:ext cx="902707" cy="301761"/>
+              </a:xfrm>
+              <a:prstGeom prst="rect">
+                <a:avLst/>
+              </a:prstGeom>
+              <a:noFill/>
+            </p:spPr>
+            <p:txBody>
+              <a:bodyPr wrap="square">
+                <a:spAutoFit/>
+              </a:bodyPr>
+              <a:lstStyle/>
+              <a:p>
+                <a:pPr algn="ctr">
+                  <a:lnSpc>
+                    <a:spcPts val="1000"/>
+                  </a:lnSpc>
+                </a:pPr>
+                <a:r>
+                  <a:rPr lang="en-US" sz="1200" dirty="0">
+                    <a:solidFill>
+                      <a:srgbClr val="C00000"/>
+                    </a:solidFill>
+                    <a:ea typeface="Helvetica Neue" panose="02000503000000020004" pitchFamily="2" charset="0"/>
+                    <a:cs typeface="Helvetica Neue" panose="02000503000000020004" pitchFamily="2" charset="0"/>
+                  </a:rPr>
+                  <a:t>Lead-time–conditioned recent dynamics</a:t>
+                </a:r>
+              </a:p>
+            </p:txBody>
+          </p:sp>
+          <p:sp>
+            <p:nvSpPr>
+              <p:cNvPr id="115" name="Oval 114">
+                <a:extLst>
+                  <a:ext uri="{FF2B5EF4-FFF2-40B4-BE49-F238E27FC236}">
+                    <a16:creationId xmlns:a16="http://schemas.microsoft.com/office/drawing/2014/main" id="{3C5733F3-C1A5-6508-350E-60E65748127A}"/>
+                  </a:ext>
+                </a:extLst>
+              </p:cNvPr>
+              <p:cNvSpPr/>
+              <p:nvPr/>
+            </p:nvSpPr>
+            <p:spPr>
+              <a:xfrm>
+                <a:off x="2298792" y="949317"/>
+                <a:ext cx="91440" cy="91440"/>
+              </a:xfrm>
+              <a:prstGeom prst="ellipse">
+                <a:avLst/>
+              </a:prstGeom>
+              <a:solidFill>
+                <a:srgbClr val="C00000"/>
+              </a:solidFill>
+              <a:ln w="9525"/>
+            </p:spPr>
+            <p:style>
+              <a:lnRef idx="2">
+                <a:schemeClr val="accent1">
+                  <a:shade val="15000"/>
+                </a:schemeClr>
+              </a:lnRef>
+              <a:fillRef idx="1">
+                <a:schemeClr val="accent1"/>
+              </a:fillRef>
+              <a:effectRef idx="0">
+                <a:schemeClr val="accent1"/>
+              </a:effectRef>
+              <a:fontRef idx="minor">
+                <a:schemeClr val="lt1"/>
+              </a:fontRef>
+            </p:style>
+            <p:txBody>
+              <a:bodyPr rtlCol="0" anchor="ctr"/>
+              <a:lstStyle/>
+              <a:p>
+                <a:pPr algn="ctr"/>
+                <a:endParaRPr lang="en-US" sz="1200">
+                  <a:ea typeface="Helvetica Neue" panose="02000503000000020004" pitchFamily="2" charset="0"/>
+                  <a:cs typeface="Helvetica Neue" panose="02000503000000020004" pitchFamily="2" charset="0"/>
+                </a:endParaRPr>
+              </a:p>
+            </p:txBody>
+          </p:sp>
+          <p:sp>
+            <p:nvSpPr>
+              <p:cNvPr id="116" name="Oval 115">
+                <a:extLst>
+                  <a:ext uri="{FF2B5EF4-FFF2-40B4-BE49-F238E27FC236}">
+                    <a16:creationId xmlns:a16="http://schemas.microsoft.com/office/drawing/2014/main" id="{5E4D40E6-E131-9DF8-F32C-07B601DB354F}"/>
+                  </a:ext>
+                </a:extLst>
+              </p:cNvPr>
+              <p:cNvSpPr/>
+              <p:nvPr/>
+            </p:nvSpPr>
+            <p:spPr>
+              <a:xfrm>
+                <a:off x="2204042" y="1145347"/>
+                <a:ext cx="91440" cy="91440"/>
+              </a:xfrm>
+              <a:prstGeom prst="ellipse">
+                <a:avLst/>
+              </a:prstGeom>
+              <a:solidFill>
+                <a:srgbClr val="C00000"/>
+              </a:solidFill>
+              <a:ln w="9525"/>
+            </p:spPr>
+            <p:style>
+              <a:lnRef idx="2">
+                <a:schemeClr val="accent1">
+                  <a:shade val="15000"/>
+                </a:schemeClr>
+              </a:lnRef>
+              <a:fillRef idx="1">
+                <a:schemeClr val="accent1"/>
+              </a:fillRef>
+              <a:effectRef idx="0">
+                <a:schemeClr val="accent1"/>
+              </a:effectRef>
+              <a:fontRef idx="minor">
+                <a:schemeClr val="lt1"/>
+              </a:fontRef>
+            </p:style>
+            <p:txBody>
+              <a:bodyPr rtlCol="0" anchor="ctr"/>
+              <a:lstStyle/>
+              <a:p>
+                <a:pPr algn="ctr"/>
+                <a:endParaRPr lang="en-US" sz="1200">
+                  <a:ea typeface="Helvetica Neue" panose="02000503000000020004" pitchFamily="2" charset="0"/>
+                  <a:cs typeface="Helvetica Neue" panose="02000503000000020004" pitchFamily="2" charset="0"/>
+                </a:endParaRPr>
+              </a:p>
+            </p:txBody>
+          </p:sp>
+          <p:sp>
+            <p:nvSpPr>
+              <p:cNvPr id="117" name="Oval 116">
+                <a:extLst>
+                  <a:ext uri="{FF2B5EF4-FFF2-40B4-BE49-F238E27FC236}">
+                    <a16:creationId xmlns:a16="http://schemas.microsoft.com/office/drawing/2014/main" id="{356C8965-D0D7-3642-119E-9ADDFBD4881D}"/>
+                  </a:ext>
+                </a:extLst>
+              </p:cNvPr>
+              <p:cNvSpPr/>
+              <p:nvPr/>
+            </p:nvSpPr>
+            <p:spPr>
+              <a:xfrm>
+                <a:off x="2087237" y="1012185"/>
+                <a:ext cx="91440" cy="91440"/>
+              </a:xfrm>
+              <a:prstGeom prst="ellipse">
+                <a:avLst/>
+              </a:prstGeom>
+              <a:solidFill>
+                <a:srgbClr val="C00000"/>
+              </a:solidFill>
+              <a:ln w="9525"/>
+            </p:spPr>
+            <p:style>
+              <a:lnRef idx="2">
+                <a:schemeClr val="accent1">
+                  <a:shade val="15000"/>
+                </a:schemeClr>
+              </a:lnRef>
+              <a:fillRef idx="1">
+                <a:schemeClr val="accent1"/>
+              </a:fillRef>
+              <a:effectRef idx="0">
+                <a:schemeClr val="accent1"/>
+              </a:effectRef>
+              <a:fontRef idx="minor">
+                <a:schemeClr val="lt1"/>
+              </a:fontRef>
+            </p:style>
+            <p:txBody>
+              <a:bodyPr rtlCol="0" anchor="ctr"/>
+              <a:lstStyle/>
+              <a:p>
+                <a:pPr algn="ctr"/>
+                <a:endParaRPr lang="en-US" sz="1200">
+                  <a:ea typeface="Helvetica Neue" panose="02000503000000020004" pitchFamily="2" charset="0"/>
+                  <a:cs typeface="Helvetica Neue" panose="02000503000000020004" pitchFamily="2" charset="0"/>
+                </a:endParaRPr>
+              </a:p>
+            </p:txBody>
+          </p:sp>
+        </p:grpSp>
+      </p:grpSp>
     </p:spTree>
     <p:extLst>
       <p:ext uri="{BB962C8B-B14F-4D97-AF65-F5344CB8AC3E}">
@@ -4053,7 +7230,7 @@
         </p:blipFill>
         <p:spPr>
           <a:xfrm>
-            <a:off x="2749550" y="153233"/>
+            <a:off x="2749550" y="309350"/>
             <a:ext cx="6045200" cy="3340100"/>
           </a:xfrm>
           <a:prstGeom prst="rect">

</xml_diff>